<commit_message>
Update presentation: Add LeakGuard branding, remove team name, update team lead Sachin.N Rithish.P, premium leak image v2
Co-authored-by: arena-agent <297053741+arena-agent@users.noreply.github.com>
</commit_message>
<xml_diff>
--- a/Autonomous_Edge_AI_Robot_Presentation.pptx
+++ b/Autonomous_Edge_AI_Robot_Presentation.pptx
@@ -3287,7 +3287,7 @@
               </a:defRPr>
             </a:pPr>
             <a:r>
-              <a:t>INDUSTRIAL PROJECT  •  2026</a:t>
+              <a:t>INDUSTRIAL PROJECT  •  2026  •  LEAKGUARD</a:t>
             </a:r>
           </a:p>
         </p:txBody>
@@ -3300,8 +3300,8 @@
         </p:nvSpPr>
         <p:spPr>
           <a:xfrm>
-            <a:off x="731520" y="1097280"/>
-            <a:ext cx="7772400" cy="2011680"/>
+            <a:off x="731520" y="1051560"/>
+            <a:ext cx="7772400" cy="2194560"/>
           </a:xfrm>
           <a:prstGeom prst="rect">
             <a:avLst/>
@@ -3315,13 +3315,29 @@
           <a:lstStyle/>
           <a:p>
             <a:pPr>
+              <a:spcAft>
+                <a:spcPts val="200"/>
+              </a:spcAft>
+              <a:defRPr sz="5400" b="1">
+                <a:solidFill>
+                  <a:srgbClr val="00D4FF"/>
+                </a:solidFill>
+                <a:latin typeface="Calibri"/>
+              </a:defRPr>
+            </a:pPr>
+            <a:r>
+              <a:t>LeakGuard</a:t>
+            </a:r>
+          </a:p>
+          <a:p>
+            <a:pPr>
               <a:lnSpc>
-                <a:spcPct val="110000"/>
+                <a:spcPct val="105000"/>
               </a:lnSpc>
               <a:spcAft>
                 <a:spcPts val="600"/>
               </a:spcAft>
-              <a:defRPr sz="4000" b="1">
+              <a:defRPr sz="3200" b="1">
                 <a:solidFill>
                   <a:srgbClr val="FFFFFF"/>
                 </a:solidFill>
@@ -3346,8 +3362,8 @@
         </p:nvSpPr>
         <p:spPr>
           <a:xfrm>
-            <a:off x="731520" y="3017520"/>
-            <a:ext cx="5486400" cy="548640"/>
+            <a:off x="731520" y="3154680"/>
+            <a:ext cx="5943600" cy="548640"/>
           </a:xfrm>
           <a:prstGeom prst="rect">
             <a:avLst/>
@@ -3361,7 +3377,7 @@
           <a:lstStyle/>
           <a:p>
             <a:pPr>
-              <a:defRPr sz="2000" b="0">
+              <a:defRPr sz="1800">
                 <a:solidFill>
                   <a:srgbClr val="4DA3FF"/>
                 </a:solidFill>
@@ -3382,7 +3398,7 @@
         </p:nvSpPr>
         <p:spPr>
           <a:xfrm>
-            <a:off x="731520" y="3611880"/>
+            <a:off x="731520" y="3703320"/>
             <a:ext cx="5029200" cy="12700"/>
           </a:xfrm>
           <a:prstGeom prst="rect">
@@ -3425,8 +3441,8 @@
         </p:nvSpPr>
         <p:spPr>
           <a:xfrm>
-            <a:off x="731520" y="4114800"/>
-            <a:ext cx="4754880" cy="1828800"/>
+            <a:off x="731520" y="3977639"/>
+            <a:ext cx="4754880" cy="2194560"/>
           </a:xfrm>
           <a:prstGeom prst="roundRect">
             <a:avLst/>
@@ -3470,8 +3486,8 @@
         </p:nvSpPr>
         <p:spPr>
           <a:xfrm>
-            <a:off x="1005840" y="4251960"/>
-            <a:ext cx="4389120" cy="320040"/>
+            <a:off x="1005840" y="4114800"/>
+            <a:ext cx="4389120" cy="365760"/>
           </a:xfrm>
           <a:prstGeom prst="rect">
             <a:avLst/>
@@ -3493,7 +3509,7 @@
               </a:defRPr>
             </a:pPr>
             <a:r>
-              <a:t>TEAM DETAILS</a:t>
+              <a:t>PROJECT TEAM</a:t>
             </a:r>
           </a:p>
         </p:txBody>
@@ -3506,8 +3522,8 @@
         </p:nvSpPr>
         <p:spPr>
           <a:xfrm>
-            <a:off x="1005840" y="4572000"/>
-            <a:ext cx="4389120" cy="320040"/>
+            <a:off x="1005840" y="4498848"/>
+            <a:ext cx="4389120" cy="365760"/>
           </a:xfrm>
           <a:prstGeom prst="rect">
             <a:avLst/>
@@ -3521,15 +3537,15 @@
           <a:lstStyle/>
           <a:p>
             <a:pPr algn="l">
-              <a:defRPr sz="1300" b="0">
-                <a:solidFill>
-                  <a:srgbClr val="DCE6F5"/>
+              <a:defRPr sz="1400" b="1">
+                <a:solidFill>
+                  <a:srgbClr val="FFFFFF"/>
                 </a:solidFill>
                 <a:latin typeface="Calibri"/>
               </a:defRPr>
             </a:pPr>
             <a:r>
-              <a:t>Team Name:  [Your Team Name]</a:t>
+              <a:t>Team Lead:  Sachin.N</a:t>
             </a:r>
           </a:p>
         </p:txBody>
@@ -3542,8 +3558,8 @@
         </p:nvSpPr>
         <p:spPr>
           <a:xfrm>
-            <a:off x="1005840" y="4892040"/>
-            <a:ext cx="4389120" cy="320040"/>
+            <a:off x="1005840" y="4882896"/>
+            <a:ext cx="4389120" cy="365760"/>
           </a:xfrm>
           <a:prstGeom prst="rect">
             <a:avLst/>
@@ -3559,13 +3575,13 @@
             <a:pPr algn="l">
               <a:defRPr sz="1300" b="0">
                 <a:solidFill>
-                  <a:srgbClr val="A0AFC3"/>
+                  <a:srgbClr val="DCE6F5"/>
                 </a:solidFill>
                 <a:latin typeface="Calibri"/>
               </a:defRPr>
             </a:pPr>
             <a:r>
-              <a:t>Members:  [Member 1, Member 2, Member 3]</a:t>
+              <a:t>Member 1:  Rithish.P</a:t>
             </a:r>
           </a:p>
         </p:txBody>
@@ -3578,8 +3594,8 @@
         </p:nvSpPr>
         <p:spPr>
           <a:xfrm>
-            <a:off x="1005840" y="5212079"/>
-            <a:ext cx="4389120" cy="320040"/>
+            <a:off x="1005840" y="5266944"/>
+            <a:ext cx="4389120" cy="365760"/>
           </a:xfrm>
           <a:prstGeom prst="rect">
             <a:avLst/>
@@ -3601,7 +3617,7 @@
               </a:defRPr>
             </a:pPr>
             <a:r>
-              <a:t>Guide:  [Guide Name]  |  Dept:  [ECE / EEE / Mechatronics]</a:t>
+              <a:t>Member 2:  [Add Name]</a:t>
             </a:r>
           </a:p>
         </p:txBody>
@@ -3614,8 +3630,8 @@
         </p:nvSpPr>
         <p:spPr>
           <a:xfrm>
-            <a:off x="1005840" y="5532120"/>
-            <a:ext cx="4389120" cy="320040"/>
+            <a:off x="1005840" y="5650992"/>
+            <a:ext cx="4389120" cy="365760"/>
           </a:xfrm>
           <a:prstGeom prst="rect">
             <a:avLst/>
@@ -3629,7 +3645,7 @@
           <a:lstStyle/>
           <a:p>
             <a:pPr algn="l">
-              <a:defRPr sz="1300" b="0">
+              <a:defRPr sz="1200" b="0">
                 <a:solidFill>
                   <a:srgbClr val="A0AFC3"/>
                 </a:solidFill>
@@ -3637,7 +3653,7 @@
               </a:defRPr>
             </a:pPr>
             <a:r>
-              <a:t>College:  [Your College Name]</a:t>
+              <a:t>Dept:  ECE / EEE / Mechatronics  |  2026</a:t>
             </a:r>
           </a:p>
         </p:txBody>
@@ -3712,13 +3728,13 @@
             <a:pPr algn="ctr">
               <a:defRPr sz="1000" b="1">
                 <a:solidFill>
-                  <a:srgbClr val="4DA3FF"/>
+                  <a:srgbClr val="00D4FF"/>
                 </a:solidFill>
                 <a:latin typeface="Calibri"/>
               </a:defRPr>
             </a:pPr>
             <a:r>
-              <a:t>●  EDGE AI  •  ROBOTICS</a:t>
+              <a:t>●  LEAKGUARD  •  EDGE AI</a:t>
             </a:r>
           </a:p>
         </p:txBody>
@@ -3972,7 +3988,7 @@
               <a:spcAft>
                 <a:spcPts val="1400"/>
               </a:spcAft>
-              <a:defRPr sz="1700" b="0">
+              <a:defRPr sz="1700">
                 <a:solidFill>
                   <a:srgbClr val="DCE6F5"/>
                 </a:solidFill>
@@ -3991,7 +4007,7 @@
               <a:spcAft>
                 <a:spcPts val="1400"/>
               </a:spcAft>
-              <a:defRPr sz="1700" b="0">
+              <a:defRPr sz="1700">
                 <a:solidFill>
                   <a:srgbClr val="DCE6F5"/>
                 </a:solidFill>
@@ -4010,7 +4026,7 @@
               <a:spcAft>
                 <a:spcPts val="1400"/>
               </a:spcAft>
-              <a:defRPr sz="1700" b="0">
+              <a:defRPr sz="1700">
                 <a:solidFill>
                   <a:srgbClr val="DCE6F5"/>
                 </a:solidFill>
@@ -4029,7 +4045,7 @@
               <a:spcAft>
                 <a:spcPts val="1400"/>
               </a:spcAft>
-              <a:defRPr sz="1700" b="0">
+              <a:defRPr sz="1700">
                 <a:solidFill>
                   <a:srgbClr val="DCE6F5"/>
                 </a:solidFill>
@@ -4048,7 +4064,7 @@
               <a:spcAft>
                 <a:spcPts val="1400"/>
               </a:spcAft>
-              <a:defRPr sz="1700" b="0">
+              <a:defRPr sz="1700">
                 <a:solidFill>
                   <a:srgbClr val="DCE6F5"/>
                 </a:solidFill>
@@ -4067,7 +4083,7 @@
               <a:spcAft>
                 <a:spcPts val="1400"/>
               </a:spcAft>
-              <a:defRPr sz="1700" b="0">
+              <a:defRPr sz="1700">
                 <a:solidFill>
                   <a:srgbClr val="DCE6F5"/>
                 </a:solidFill>
@@ -4086,7 +4102,7 @@
               <a:spcAft>
                 <a:spcPts val="1400"/>
               </a:spcAft>
-              <a:defRPr sz="1700" b="0">
+              <a:defRPr sz="1700">
                 <a:solidFill>
                   <a:srgbClr val="DCE6F5"/>
                 </a:solidFill>
@@ -4399,7 +4415,7 @@
       </p:sp>
       <p:pic>
         <p:nvPicPr>
-          <p:cNvPr id="6" name="Picture 5" descr="slide3_leak.jpg"/>
+          <p:cNvPr id="6" name="Picture 5" descr="slide3_leak_v2.jpg"/>
           <p:cNvPicPr>
             <a:picLocks noChangeAspect="1"/>
           </p:cNvPicPr>
@@ -7876,7 +7892,7 @@
           </a:prstGeom>
           <a:solidFill>
             <a:srgbClr val="070D1F">
-              <a:alpha val="75000"/>
+              <a:alpha val="80000"/>
             </a:srgbClr>
           </a:solidFill>
           <a:ln>
@@ -8218,7 +8234,7 @@
         <p:spPr>
           <a:xfrm>
             <a:off x="7132320" y="2103120"/>
-            <a:ext cx="4023360" cy="1097280"/>
+            <a:ext cx="4023360" cy="731520"/>
           </a:xfrm>
           <a:prstGeom prst="rect">
             <a:avLst/>
@@ -8232,6 +8248,42 @@
           <a:lstStyle/>
           <a:p>
             <a:pPr algn="ctr">
+              <a:defRPr sz="2200" b="1">
+                <a:solidFill>
+                  <a:srgbClr val="00D4FF"/>
+                </a:solidFill>
+                <a:latin typeface="Calibri"/>
+              </a:defRPr>
+            </a:pPr>
+            <a:r>
+              <a:t>LeakGuard</a:t>
+            </a:r>
+          </a:p>
+        </p:txBody>
+      </p:sp>
+      <p:sp>
+        <p:nvSpPr>
+          <p:cNvPr id="11" name="TextBox 10"/>
+          <p:cNvSpPr txBox="1"/>
+          <p:nvPr/>
+        </p:nvSpPr>
+        <p:spPr>
+          <a:xfrm>
+            <a:off x="7132320" y="2606040"/>
+            <a:ext cx="4023360" cy="822960"/>
+          </a:xfrm>
+          <a:prstGeom prst="rect">
+            <a:avLst/>
+          </a:prstGeom>
+          <a:noFill/>
+        </p:spPr>
+        <p:txBody>
+          <a:bodyPr wrap="square">
+            <a:spAutoFit/>
+          </a:bodyPr>
+          <a:lstStyle/>
+          <a:p>
+            <a:pPr algn="ctr">
               <a:defRPr sz="4400" b="1">
                 <a:solidFill>
                   <a:srgbClr val="FFFFFF"/>
@@ -8247,13 +8299,13 @@
       </p:sp>
       <p:sp>
         <p:nvSpPr>
-          <p:cNvPr id="11" name="Rectangle 10"/>
+          <p:cNvPr id="12" name="Rectangle 11"/>
           <p:cNvSpPr/>
           <p:nvPr/>
         </p:nvSpPr>
         <p:spPr>
           <a:xfrm>
-            <a:off x="7772400" y="3108960"/>
+            <a:off x="7772400" y="3383280"/>
             <a:ext cx="2743200" cy="25400"/>
           </a:xfrm>
           <a:prstGeom prst="rect">
@@ -8290,13 +8342,13 @@
       </p:sp>
       <p:sp>
         <p:nvSpPr>
-          <p:cNvPr id="12" name="TextBox 11"/>
+          <p:cNvPr id="13" name="TextBox 12"/>
           <p:cNvSpPr txBox="1"/>
           <p:nvPr/>
         </p:nvSpPr>
         <p:spPr>
           <a:xfrm>
-            <a:off x="7132320" y="3383280"/>
+            <a:off x="7132320" y="3611880"/>
             <a:ext cx="4023360" cy="548640"/>
           </a:xfrm>
           <a:prstGeom prst="rect">
@@ -8326,13 +8378,13 @@
       </p:sp>
       <p:sp>
         <p:nvSpPr>
-          <p:cNvPr id="13" name="TextBox 12"/>
+          <p:cNvPr id="14" name="TextBox 13"/>
           <p:cNvSpPr txBox="1"/>
           <p:nvPr/>
         </p:nvSpPr>
         <p:spPr>
           <a:xfrm>
-            <a:off x="7132320" y="3931920"/>
+            <a:off x="7132320" y="4114800"/>
             <a:ext cx="4023360" cy="548640"/>
           </a:xfrm>
           <a:prstGeom prst="rect">
@@ -8347,7 +8399,7 @@
           <a:lstStyle/>
           <a:p>
             <a:pPr algn="ctr">
-              <a:defRPr sz="1200" b="0">
+              <a:defRPr sz="1100" b="0">
                 <a:solidFill>
                   <a:srgbClr val="A0AFC3"/>
                 </a:solidFill>
@@ -8355,14 +8407,14 @@
               </a:defRPr>
             </a:pPr>
             <a:r>
-              <a:t>Smart Industrial Energy Monitoring System</a:t>
-            </a:r>
-          </a:p>
-        </p:txBody>
-      </p:sp>
-      <p:sp>
-        <p:nvSpPr>
-          <p:cNvPr id="14" name="Rectangle 13"/>
+              <a:t>Team Lead: Sachin.N | Rithish.P</a:t>
+            </a:r>
+          </a:p>
+        </p:txBody>
+      </p:sp>
+      <p:sp>
+        <p:nvSpPr>
+          <p:cNvPr id="15" name="Rectangle 14"/>
           <p:cNvSpPr/>
           <p:nvPr/>
         </p:nvSpPr>
@@ -8405,7 +8457,7 @@
       </p:sp>
       <p:sp>
         <p:nvSpPr>
-          <p:cNvPr id="15" name="TextBox 14"/>
+          <p:cNvPr id="16" name="TextBox 15"/>
           <p:cNvSpPr txBox="1"/>
           <p:nvPr/>
         </p:nvSpPr>
@@ -8434,7 +8486,7 @@
               </a:defRPr>
             </a:pPr>
             <a:r>
-              <a:t>Contact: [email@college.edu]  |  Team: [Your Team Name]  |  Project: Autonomous Edge-AI Robot for Leak Detection</a:t>
+              <a:t>LeakGuard | Autonomous Edge-AI Robot for Compressed-Air Leak Detection | Team Lead: Sachin.N</a:t>
             </a:r>
           </a:p>
         </p:txBody>

</xml_diff>

<commit_message>
LeakGuard PRO v4: fix image curve misalignment - perfect rectangle frames with corner brackets, pro-level design
Co-authored-by: arena-agent <297053741+arena-agent@users.noreply.github.com>
</commit_message>
<xml_diff>
--- a/Autonomous_Edge_AI_Robot_Presentation.pptx
+++ b/Autonomous_Edge_AI_Robot_Presentation.pptx
@@ -3690,7 +3690,7 @@
         <p:spPr>
           <a:xfrm>
             <a:off x="731520" y="685800"/>
-            <a:ext cx="4572000" cy="320040"/>
+            <a:ext cx="5029200" cy="320040"/>
           </a:xfrm>
           <a:prstGeom prst="rect">
             <a:avLst/>
@@ -5964,7 +5964,7 @@
       </p:sp>
       <p:sp>
         <p:nvSpPr>
-          <p:cNvPr id="19" name="Rounded Rectangle 18"/>
+          <p:cNvPr id="19" name="Rectangle 18"/>
           <p:cNvSpPr/>
           <p:nvPr/>
         </p:nvSpPr>
@@ -5973,7 +5973,7 @@
             <a:off x="1051560" y="5303520"/>
             <a:ext cx="5029200" cy="777240"/>
           </a:xfrm>
-          <a:prstGeom prst="roundRect">
+          <a:prstGeom prst="rect">
             <a:avLst/>
           </a:prstGeom>
           <a:solidFill>
@@ -6081,22 +6081,22 @@
       </p:sp>
       <p:sp>
         <p:nvSpPr>
-          <p:cNvPr id="22" name="Rounded Rectangle 21"/>
-          <p:cNvSpPr/>
-          <p:nvPr/>
-        </p:nvSpPr>
-        <p:spPr>
-          <a:xfrm>
-            <a:off x="6807200" y="1686560"/>
-            <a:ext cx="4673600" cy="4673600"/>
-          </a:xfrm>
-          <a:prstGeom prst="roundRect">
-            <a:avLst/>
-          </a:prstGeom>
-          <a:solidFill>
-            <a:srgbClr val="111B37"/>
-          </a:solidFill>
-          <a:ln w="19050">
+          <p:cNvPr id="22" name="Rectangle 21"/>
+          <p:cNvSpPr/>
+          <p:nvPr/>
+        </p:nvSpPr>
+        <p:spPr>
+          <a:xfrm>
+            <a:off x="6858000" y="1737360"/>
+            <a:ext cx="4572000" cy="4023360"/>
+          </a:xfrm>
+          <a:prstGeom prst="rect">
+            <a:avLst/>
+          </a:prstGeom>
+          <a:solidFill>
+            <a:srgbClr val="0C142D"/>
+          </a:solidFill>
+          <a:ln w="22860">
             <a:solidFill>
               <a:srgbClr val="00D4FF"/>
             </a:solidFill>
@@ -6140,32 +6140,419 @@
         </p:blipFill>
         <p:spPr>
           <a:xfrm>
+            <a:off x="6890004" y="1769364"/>
+            <a:ext cx="4507992" cy="3959352"/>
+          </a:xfrm>
+          <a:prstGeom prst="rect">
+            <a:avLst/>
+          </a:prstGeom>
+        </p:spPr>
+      </p:pic>
+      <p:sp>
+        <p:nvSpPr>
+          <p:cNvPr id="24" name="Rectangle 23"/>
+          <p:cNvSpPr/>
+          <p:nvPr/>
+        </p:nvSpPr>
+        <p:spPr>
+          <a:xfrm>
             <a:off x="6858000" y="1737360"/>
-            <a:ext cx="4572000" cy="4572000"/>
-          </a:xfrm>
-          <a:prstGeom prst="rect">
-            <a:avLst/>
-          </a:prstGeom>
-        </p:spPr>
-      </p:pic>
-      <p:sp>
-        <p:nvSpPr>
-          <p:cNvPr id="24" name="Rounded Rectangle 23"/>
-          <p:cNvSpPr/>
-          <p:nvPr/>
-        </p:nvSpPr>
-        <p:spPr>
-          <a:xfrm>
-            <a:off x="7040880" y="5669280"/>
-            <a:ext cx="4206240" cy="457200"/>
-          </a:xfrm>
-          <a:prstGeom prst="roundRect">
+            <a:ext cx="4572000" cy="38100"/>
+          </a:xfrm>
+          <a:prstGeom prst="rect">
+            <a:avLst/>
+          </a:prstGeom>
+          <a:solidFill>
+            <a:srgbClr val="00D4FF"/>
+          </a:solidFill>
+          <a:ln>
+            <a:noFill/>
+          </a:ln>
+        </p:spPr>
+        <p:style>
+          <a:lnRef idx="1">
+            <a:schemeClr val="accent1"/>
+          </a:lnRef>
+          <a:fillRef idx="3">
+            <a:schemeClr val="accent1"/>
+          </a:fillRef>
+          <a:effectRef idx="2">
+            <a:schemeClr val="accent1"/>
+          </a:effectRef>
+          <a:fontRef idx="minor">
+            <a:schemeClr val="lt1"/>
+          </a:fontRef>
+        </p:style>
+        <p:txBody>
+          <a:bodyPr rtlCol="0" anchor="ctr"/>
+          <a:lstStyle/>
+          <a:p>
+            <a:pPr algn="ctr"/>
+          </a:p>
+        </p:txBody>
+      </p:sp>
+      <p:sp>
+        <p:nvSpPr>
+          <p:cNvPr id="25" name="Rectangle 24"/>
+          <p:cNvSpPr/>
+          <p:nvPr/>
+        </p:nvSpPr>
+        <p:spPr>
+          <a:xfrm>
+            <a:off x="6858000" y="1737360"/>
+            <a:ext cx="164592" cy="38100"/>
+          </a:xfrm>
+          <a:prstGeom prst="rect">
+            <a:avLst/>
+          </a:prstGeom>
+          <a:solidFill>
+            <a:srgbClr val="00D4FF"/>
+          </a:solidFill>
+          <a:ln>
+            <a:noFill/>
+          </a:ln>
+        </p:spPr>
+        <p:style>
+          <a:lnRef idx="1">
+            <a:schemeClr val="accent1"/>
+          </a:lnRef>
+          <a:fillRef idx="3">
+            <a:schemeClr val="accent1"/>
+          </a:fillRef>
+          <a:effectRef idx="2">
+            <a:schemeClr val="accent1"/>
+          </a:effectRef>
+          <a:fontRef idx="minor">
+            <a:schemeClr val="lt1"/>
+          </a:fontRef>
+        </p:style>
+        <p:txBody>
+          <a:bodyPr rtlCol="0" anchor="ctr"/>
+          <a:lstStyle/>
+          <a:p>
+            <a:pPr algn="ctr"/>
+          </a:p>
+        </p:txBody>
+      </p:sp>
+      <p:sp>
+        <p:nvSpPr>
+          <p:cNvPr id="26" name="Rectangle 25"/>
+          <p:cNvSpPr/>
+          <p:nvPr/>
+        </p:nvSpPr>
+        <p:spPr>
+          <a:xfrm>
+            <a:off x="6858000" y="1737360"/>
+            <a:ext cx="38100" cy="164592"/>
+          </a:xfrm>
+          <a:prstGeom prst="rect">
+            <a:avLst/>
+          </a:prstGeom>
+          <a:solidFill>
+            <a:srgbClr val="00D4FF"/>
+          </a:solidFill>
+          <a:ln>
+            <a:noFill/>
+          </a:ln>
+        </p:spPr>
+        <p:style>
+          <a:lnRef idx="1">
+            <a:schemeClr val="accent1"/>
+          </a:lnRef>
+          <a:fillRef idx="3">
+            <a:schemeClr val="accent1"/>
+          </a:fillRef>
+          <a:effectRef idx="2">
+            <a:schemeClr val="accent1"/>
+          </a:effectRef>
+          <a:fontRef idx="minor">
+            <a:schemeClr val="lt1"/>
+          </a:fontRef>
+        </p:style>
+        <p:txBody>
+          <a:bodyPr rtlCol="0" anchor="ctr"/>
+          <a:lstStyle/>
+          <a:p>
+            <a:pPr algn="ctr"/>
+          </a:p>
+        </p:txBody>
+      </p:sp>
+      <p:sp>
+        <p:nvSpPr>
+          <p:cNvPr id="27" name="Rectangle 26"/>
+          <p:cNvSpPr/>
+          <p:nvPr/>
+        </p:nvSpPr>
+        <p:spPr>
+          <a:xfrm>
+            <a:off x="11265408" y="1737360"/>
+            <a:ext cx="164592" cy="38100"/>
+          </a:xfrm>
+          <a:prstGeom prst="rect">
+            <a:avLst/>
+          </a:prstGeom>
+          <a:solidFill>
+            <a:srgbClr val="00D4FF"/>
+          </a:solidFill>
+          <a:ln>
+            <a:noFill/>
+          </a:ln>
+        </p:spPr>
+        <p:style>
+          <a:lnRef idx="1">
+            <a:schemeClr val="accent1"/>
+          </a:lnRef>
+          <a:fillRef idx="3">
+            <a:schemeClr val="accent1"/>
+          </a:fillRef>
+          <a:effectRef idx="2">
+            <a:schemeClr val="accent1"/>
+          </a:effectRef>
+          <a:fontRef idx="minor">
+            <a:schemeClr val="lt1"/>
+          </a:fontRef>
+        </p:style>
+        <p:txBody>
+          <a:bodyPr rtlCol="0" anchor="ctr"/>
+          <a:lstStyle/>
+          <a:p>
+            <a:pPr algn="ctr"/>
+          </a:p>
+        </p:txBody>
+      </p:sp>
+      <p:sp>
+        <p:nvSpPr>
+          <p:cNvPr id="28" name="Rectangle 27"/>
+          <p:cNvSpPr/>
+          <p:nvPr/>
+        </p:nvSpPr>
+        <p:spPr>
+          <a:xfrm>
+            <a:off x="11391900" y="1737360"/>
+            <a:ext cx="38100" cy="164592"/>
+          </a:xfrm>
+          <a:prstGeom prst="rect">
+            <a:avLst/>
+          </a:prstGeom>
+          <a:solidFill>
+            <a:srgbClr val="00D4FF"/>
+          </a:solidFill>
+          <a:ln>
+            <a:noFill/>
+          </a:ln>
+        </p:spPr>
+        <p:style>
+          <a:lnRef idx="1">
+            <a:schemeClr val="accent1"/>
+          </a:lnRef>
+          <a:fillRef idx="3">
+            <a:schemeClr val="accent1"/>
+          </a:fillRef>
+          <a:effectRef idx="2">
+            <a:schemeClr val="accent1"/>
+          </a:effectRef>
+          <a:fontRef idx="minor">
+            <a:schemeClr val="lt1"/>
+          </a:fontRef>
+        </p:style>
+        <p:txBody>
+          <a:bodyPr rtlCol="0" anchor="ctr"/>
+          <a:lstStyle/>
+          <a:p>
+            <a:pPr algn="ctr"/>
+          </a:p>
+        </p:txBody>
+      </p:sp>
+      <p:sp>
+        <p:nvSpPr>
+          <p:cNvPr id="29" name="Rectangle 28"/>
+          <p:cNvSpPr/>
+          <p:nvPr/>
+        </p:nvSpPr>
+        <p:spPr>
+          <a:xfrm>
+            <a:off x="6858000" y="5722620"/>
+            <a:ext cx="164592" cy="38100"/>
+          </a:xfrm>
+          <a:prstGeom prst="rect">
+            <a:avLst/>
+          </a:prstGeom>
+          <a:solidFill>
+            <a:srgbClr val="4DA3FF"/>
+          </a:solidFill>
+          <a:ln>
+            <a:noFill/>
+          </a:ln>
+        </p:spPr>
+        <p:style>
+          <a:lnRef idx="1">
+            <a:schemeClr val="accent1"/>
+          </a:lnRef>
+          <a:fillRef idx="3">
+            <a:schemeClr val="accent1"/>
+          </a:fillRef>
+          <a:effectRef idx="2">
+            <a:schemeClr val="accent1"/>
+          </a:effectRef>
+          <a:fontRef idx="minor">
+            <a:schemeClr val="lt1"/>
+          </a:fontRef>
+        </p:style>
+        <p:txBody>
+          <a:bodyPr rtlCol="0" anchor="ctr"/>
+          <a:lstStyle/>
+          <a:p>
+            <a:pPr algn="ctr"/>
+          </a:p>
+        </p:txBody>
+      </p:sp>
+      <p:sp>
+        <p:nvSpPr>
+          <p:cNvPr id="30" name="Rectangle 29"/>
+          <p:cNvSpPr/>
+          <p:nvPr/>
+        </p:nvSpPr>
+        <p:spPr>
+          <a:xfrm>
+            <a:off x="6858000" y="5596128"/>
+            <a:ext cx="38100" cy="164592"/>
+          </a:xfrm>
+          <a:prstGeom prst="rect">
+            <a:avLst/>
+          </a:prstGeom>
+          <a:solidFill>
+            <a:srgbClr val="4DA3FF"/>
+          </a:solidFill>
+          <a:ln>
+            <a:noFill/>
+          </a:ln>
+        </p:spPr>
+        <p:style>
+          <a:lnRef idx="1">
+            <a:schemeClr val="accent1"/>
+          </a:lnRef>
+          <a:fillRef idx="3">
+            <a:schemeClr val="accent1"/>
+          </a:fillRef>
+          <a:effectRef idx="2">
+            <a:schemeClr val="accent1"/>
+          </a:effectRef>
+          <a:fontRef idx="minor">
+            <a:schemeClr val="lt1"/>
+          </a:fontRef>
+        </p:style>
+        <p:txBody>
+          <a:bodyPr rtlCol="0" anchor="ctr"/>
+          <a:lstStyle/>
+          <a:p>
+            <a:pPr algn="ctr"/>
+          </a:p>
+        </p:txBody>
+      </p:sp>
+      <p:sp>
+        <p:nvSpPr>
+          <p:cNvPr id="31" name="Rectangle 30"/>
+          <p:cNvSpPr/>
+          <p:nvPr/>
+        </p:nvSpPr>
+        <p:spPr>
+          <a:xfrm>
+            <a:off x="11265408" y="5722620"/>
+            <a:ext cx="164592" cy="38100"/>
+          </a:xfrm>
+          <a:prstGeom prst="rect">
+            <a:avLst/>
+          </a:prstGeom>
+          <a:solidFill>
+            <a:srgbClr val="4DA3FF"/>
+          </a:solidFill>
+          <a:ln>
+            <a:noFill/>
+          </a:ln>
+        </p:spPr>
+        <p:style>
+          <a:lnRef idx="1">
+            <a:schemeClr val="accent1"/>
+          </a:lnRef>
+          <a:fillRef idx="3">
+            <a:schemeClr val="accent1"/>
+          </a:fillRef>
+          <a:effectRef idx="2">
+            <a:schemeClr val="accent1"/>
+          </a:effectRef>
+          <a:fontRef idx="minor">
+            <a:schemeClr val="lt1"/>
+          </a:fontRef>
+        </p:style>
+        <p:txBody>
+          <a:bodyPr rtlCol="0" anchor="ctr"/>
+          <a:lstStyle/>
+          <a:p>
+            <a:pPr algn="ctr"/>
+          </a:p>
+        </p:txBody>
+      </p:sp>
+      <p:sp>
+        <p:nvSpPr>
+          <p:cNvPr id="32" name="Rectangle 31"/>
+          <p:cNvSpPr/>
+          <p:nvPr/>
+        </p:nvSpPr>
+        <p:spPr>
+          <a:xfrm>
+            <a:off x="11391900" y="5596128"/>
+            <a:ext cx="38100" cy="164592"/>
+          </a:xfrm>
+          <a:prstGeom prst="rect">
+            <a:avLst/>
+          </a:prstGeom>
+          <a:solidFill>
+            <a:srgbClr val="4DA3FF"/>
+          </a:solidFill>
+          <a:ln>
+            <a:noFill/>
+          </a:ln>
+        </p:spPr>
+        <p:style>
+          <a:lnRef idx="1">
+            <a:schemeClr val="accent1"/>
+          </a:lnRef>
+          <a:fillRef idx="3">
+            <a:schemeClr val="accent1"/>
+          </a:fillRef>
+          <a:effectRef idx="2">
+            <a:schemeClr val="accent1"/>
+          </a:effectRef>
+          <a:fontRef idx="minor">
+            <a:schemeClr val="lt1"/>
+          </a:fontRef>
+        </p:style>
+        <p:txBody>
+          <a:bodyPr rtlCol="0" anchor="ctr"/>
+          <a:lstStyle/>
+          <a:p>
+            <a:pPr algn="ctr"/>
+          </a:p>
+        </p:txBody>
+      </p:sp>
+      <p:sp>
+        <p:nvSpPr>
+          <p:cNvPr id="33" name="Rectangle 32"/>
+          <p:cNvSpPr/>
+          <p:nvPr/>
+        </p:nvSpPr>
+        <p:spPr>
+          <a:xfrm>
+            <a:off x="6858000" y="5760720"/>
+            <a:ext cx="4572000" cy="457200"/>
+          </a:xfrm>
+          <a:prstGeom prst="rect">
             <a:avLst/>
           </a:prstGeom>
           <a:solidFill>
             <a:srgbClr val="0A193C"/>
           </a:solidFill>
-          <a:ln w="10160">
+          <a:ln w="12700">
             <a:solidFill>
               <a:srgbClr val="00D4FF"/>
             </a:solidFill>
@@ -6195,14 +6582,14 @@
       </p:sp>
       <p:sp>
         <p:nvSpPr>
-          <p:cNvPr id="25" name="TextBox 24"/>
+          <p:cNvPr id="34" name="TextBox 33"/>
           <p:cNvSpPr txBox="1"/>
           <p:nvPr/>
         </p:nvSpPr>
         <p:spPr>
           <a:xfrm>
-            <a:off x="7040880" y="5669280"/>
-            <a:ext cx="4206240" cy="457200"/>
+            <a:off x="6858000" y="5760720"/>
+            <a:ext cx="4572000" cy="457200"/>
           </a:xfrm>
           <a:prstGeom prst="rect">
             <a:avLst/>
@@ -6231,7 +6618,7 @@
       </p:sp>
       <p:sp>
         <p:nvSpPr>
-          <p:cNvPr id="26" name="Oval 25"/>
+          <p:cNvPr id="35" name="Oval 34"/>
           <p:cNvSpPr/>
           <p:nvPr/>
         </p:nvSpPr>
@@ -6274,7 +6661,7 @@
       </p:sp>
       <p:sp>
         <p:nvSpPr>
-          <p:cNvPr id="27" name="Oval 26"/>
+          <p:cNvPr id="36" name="Oval 35"/>
           <p:cNvSpPr/>
           <p:nvPr/>
         </p:nvSpPr>
@@ -6317,7 +6704,7 @@
       </p:sp>
       <p:sp>
         <p:nvSpPr>
-          <p:cNvPr id="28" name="Oval 27"/>
+          <p:cNvPr id="37" name="Oval 36"/>
           <p:cNvSpPr/>
           <p:nvPr/>
         </p:nvSpPr>
@@ -6360,7 +6747,7 @@
       </p:sp>
       <p:sp>
         <p:nvSpPr>
-          <p:cNvPr id="29" name="Oval 28"/>
+          <p:cNvPr id="38" name="Oval 37"/>
           <p:cNvSpPr/>
           <p:nvPr/>
         </p:nvSpPr>
@@ -6403,7 +6790,7 @@
       </p:sp>
       <p:sp>
         <p:nvSpPr>
-          <p:cNvPr id="30" name="Oval 29"/>
+          <p:cNvPr id="39" name="Oval 38"/>
           <p:cNvSpPr/>
           <p:nvPr/>
         </p:nvSpPr>
@@ -6446,7 +6833,7 @@
       </p:sp>
       <p:sp>
         <p:nvSpPr>
-          <p:cNvPr id="31" name="Oval 30"/>
+          <p:cNvPr id="40" name="Oval 39"/>
           <p:cNvSpPr/>
           <p:nvPr/>
         </p:nvSpPr>
@@ -6489,7 +6876,7 @@
       </p:sp>
       <p:sp>
         <p:nvSpPr>
-          <p:cNvPr id="32" name="Oval 31"/>
+          <p:cNvPr id="41" name="Oval 40"/>
           <p:cNvSpPr/>
           <p:nvPr/>
         </p:nvSpPr>
@@ -6532,7 +6919,7 @@
       </p:sp>
       <p:sp>
         <p:nvSpPr>
-          <p:cNvPr id="33" name="Oval 32"/>
+          <p:cNvPr id="42" name="Oval 41"/>
           <p:cNvSpPr/>
           <p:nvPr/>
         </p:nvSpPr>
@@ -6575,7 +6962,7 @@
       </p:sp>
       <p:sp>
         <p:nvSpPr>
-          <p:cNvPr id="34" name="Oval 33"/>
+          <p:cNvPr id="43" name="Oval 42"/>
           <p:cNvSpPr/>
           <p:nvPr/>
         </p:nvSpPr>
@@ -6618,7 +7005,7 @@
       </p:sp>
       <p:sp>
         <p:nvSpPr>
-          <p:cNvPr id="35" name="Oval 34"/>
+          <p:cNvPr id="44" name="Oval 43"/>
           <p:cNvSpPr/>
           <p:nvPr/>
         </p:nvSpPr>
@@ -6661,7 +7048,7 @@
       </p:sp>
       <p:sp>
         <p:nvSpPr>
-          <p:cNvPr id="36" name="Oval 35"/>
+          <p:cNvPr id="45" name="Oval 44"/>
           <p:cNvSpPr/>
           <p:nvPr/>
         </p:nvSpPr>
@@ -6704,7 +7091,7 @@
       </p:sp>
       <p:sp>
         <p:nvSpPr>
-          <p:cNvPr id="37" name="Oval 36"/>
+          <p:cNvPr id="46" name="Oval 45"/>
           <p:cNvSpPr/>
           <p:nvPr/>
         </p:nvSpPr>
@@ -7313,22 +7700,22 @@
       </p:sp>
       <p:sp>
         <p:nvSpPr>
-          <p:cNvPr id="15" name="Rounded Rectangle 14"/>
-          <p:cNvSpPr/>
-          <p:nvPr/>
-        </p:nvSpPr>
-        <p:spPr>
-          <a:xfrm>
-            <a:off x="6807200" y="1686560"/>
-            <a:ext cx="4673600" cy="4673600"/>
-          </a:xfrm>
-          <a:prstGeom prst="roundRect">
-            <a:avLst/>
-          </a:prstGeom>
-          <a:solidFill>
-            <a:srgbClr val="111B37"/>
-          </a:solidFill>
-          <a:ln w="19050">
+          <p:cNvPr id="15" name="Rectangle 14"/>
+          <p:cNvSpPr/>
+          <p:nvPr/>
+        </p:nvSpPr>
+        <p:spPr>
+          <a:xfrm>
+            <a:off x="6858000" y="1737360"/>
+            <a:ext cx="4572000" cy="4023360"/>
+          </a:xfrm>
+          <a:prstGeom prst="rect">
+            <a:avLst/>
+          </a:prstGeom>
+          <a:solidFill>
+            <a:srgbClr val="0C142D"/>
+          </a:solidFill>
+          <a:ln w="22860">
             <a:solidFill>
               <a:srgbClr val="FF6464"/>
             </a:solidFill>
@@ -7372,26 +7759,413 @@
         </p:blipFill>
         <p:spPr>
           <a:xfrm>
+            <a:off x="6890004" y="1769364"/>
+            <a:ext cx="4507992" cy="3959352"/>
+          </a:xfrm>
+          <a:prstGeom prst="rect">
+            <a:avLst/>
+          </a:prstGeom>
+        </p:spPr>
+      </p:pic>
+      <p:sp>
+        <p:nvSpPr>
+          <p:cNvPr id="17" name="Rectangle 16"/>
+          <p:cNvSpPr/>
+          <p:nvPr/>
+        </p:nvSpPr>
+        <p:spPr>
+          <a:xfrm>
             <a:off x="6858000" y="1737360"/>
-            <a:ext cx="4572000" cy="4572000"/>
-          </a:xfrm>
-          <a:prstGeom prst="rect">
-            <a:avLst/>
-          </a:prstGeom>
-        </p:spPr>
-      </p:pic>
-      <p:sp>
-        <p:nvSpPr>
-          <p:cNvPr id="17" name="Rounded Rectangle 16"/>
-          <p:cNvSpPr/>
-          <p:nvPr/>
-        </p:nvSpPr>
-        <p:spPr>
-          <a:xfrm>
-            <a:off x="7040880" y="1920240"/>
+            <a:ext cx="4572000" cy="38100"/>
+          </a:xfrm>
+          <a:prstGeom prst="rect">
+            <a:avLst/>
+          </a:prstGeom>
+          <a:solidFill>
+            <a:srgbClr val="FF6464"/>
+          </a:solidFill>
+          <a:ln>
+            <a:noFill/>
+          </a:ln>
+        </p:spPr>
+        <p:style>
+          <a:lnRef idx="1">
+            <a:schemeClr val="accent1"/>
+          </a:lnRef>
+          <a:fillRef idx="3">
+            <a:schemeClr val="accent1"/>
+          </a:fillRef>
+          <a:effectRef idx="2">
+            <a:schemeClr val="accent1"/>
+          </a:effectRef>
+          <a:fontRef idx="minor">
+            <a:schemeClr val="lt1"/>
+          </a:fontRef>
+        </p:style>
+        <p:txBody>
+          <a:bodyPr rtlCol="0" anchor="ctr"/>
+          <a:lstStyle/>
+          <a:p>
+            <a:pPr algn="ctr"/>
+          </a:p>
+        </p:txBody>
+      </p:sp>
+      <p:sp>
+        <p:nvSpPr>
+          <p:cNvPr id="18" name="Rectangle 17"/>
+          <p:cNvSpPr/>
+          <p:nvPr/>
+        </p:nvSpPr>
+        <p:spPr>
+          <a:xfrm>
+            <a:off x="6858000" y="1737360"/>
+            <a:ext cx="164592" cy="38100"/>
+          </a:xfrm>
+          <a:prstGeom prst="rect">
+            <a:avLst/>
+          </a:prstGeom>
+          <a:solidFill>
+            <a:srgbClr val="00D4FF"/>
+          </a:solidFill>
+          <a:ln>
+            <a:noFill/>
+          </a:ln>
+        </p:spPr>
+        <p:style>
+          <a:lnRef idx="1">
+            <a:schemeClr val="accent1"/>
+          </a:lnRef>
+          <a:fillRef idx="3">
+            <a:schemeClr val="accent1"/>
+          </a:fillRef>
+          <a:effectRef idx="2">
+            <a:schemeClr val="accent1"/>
+          </a:effectRef>
+          <a:fontRef idx="minor">
+            <a:schemeClr val="lt1"/>
+          </a:fontRef>
+        </p:style>
+        <p:txBody>
+          <a:bodyPr rtlCol="0" anchor="ctr"/>
+          <a:lstStyle/>
+          <a:p>
+            <a:pPr algn="ctr"/>
+          </a:p>
+        </p:txBody>
+      </p:sp>
+      <p:sp>
+        <p:nvSpPr>
+          <p:cNvPr id="19" name="Rectangle 18"/>
+          <p:cNvSpPr/>
+          <p:nvPr/>
+        </p:nvSpPr>
+        <p:spPr>
+          <a:xfrm>
+            <a:off x="6858000" y="1737360"/>
+            <a:ext cx="38100" cy="164592"/>
+          </a:xfrm>
+          <a:prstGeom prst="rect">
+            <a:avLst/>
+          </a:prstGeom>
+          <a:solidFill>
+            <a:srgbClr val="00D4FF"/>
+          </a:solidFill>
+          <a:ln>
+            <a:noFill/>
+          </a:ln>
+        </p:spPr>
+        <p:style>
+          <a:lnRef idx="1">
+            <a:schemeClr val="accent1"/>
+          </a:lnRef>
+          <a:fillRef idx="3">
+            <a:schemeClr val="accent1"/>
+          </a:fillRef>
+          <a:effectRef idx="2">
+            <a:schemeClr val="accent1"/>
+          </a:effectRef>
+          <a:fontRef idx="minor">
+            <a:schemeClr val="lt1"/>
+          </a:fontRef>
+        </p:style>
+        <p:txBody>
+          <a:bodyPr rtlCol="0" anchor="ctr"/>
+          <a:lstStyle/>
+          <a:p>
+            <a:pPr algn="ctr"/>
+          </a:p>
+        </p:txBody>
+      </p:sp>
+      <p:sp>
+        <p:nvSpPr>
+          <p:cNvPr id="20" name="Rectangle 19"/>
+          <p:cNvSpPr/>
+          <p:nvPr/>
+        </p:nvSpPr>
+        <p:spPr>
+          <a:xfrm>
+            <a:off x="11265408" y="1737360"/>
+            <a:ext cx="164592" cy="38100"/>
+          </a:xfrm>
+          <a:prstGeom prst="rect">
+            <a:avLst/>
+          </a:prstGeom>
+          <a:solidFill>
+            <a:srgbClr val="00D4FF"/>
+          </a:solidFill>
+          <a:ln>
+            <a:noFill/>
+          </a:ln>
+        </p:spPr>
+        <p:style>
+          <a:lnRef idx="1">
+            <a:schemeClr val="accent1"/>
+          </a:lnRef>
+          <a:fillRef idx="3">
+            <a:schemeClr val="accent1"/>
+          </a:fillRef>
+          <a:effectRef idx="2">
+            <a:schemeClr val="accent1"/>
+          </a:effectRef>
+          <a:fontRef idx="minor">
+            <a:schemeClr val="lt1"/>
+          </a:fontRef>
+        </p:style>
+        <p:txBody>
+          <a:bodyPr rtlCol="0" anchor="ctr"/>
+          <a:lstStyle/>
+          <a:p>
+            <a:pPr algn="ctr"/>
+          </a:p>
+        </p:txBody>
+      </p:sp>
+      <p:sp>
+        <p:nvSpPr>
+          <p:cNvPr id="21" name="Rectangle 20"/>
+          <p:cNvSpPr/>
+          <p:nvPr/>
+        </p:nvSpPr>
+        <p:spPr>
+          <a:xfrm>
+            <a:off x="11391900" y="1737360"/>
+            <a:ext cx="38100" cy="164592"/>
+          </a:xfrm>
+          <a:prstGeom prst="rect">
+            <a:avLst/>
+          </a:prstGeom>
+          <a:solidFill>
+            <a:srgbClr val="00D4FF"/>
+          </a:solidFill>
+          <a:ln>
+            <a:noFill/>
+          </a:ln>
+        </p:spPr>
+        <p:style>
+          <a:lnRef idx="1">
+            <a:schemeClr val="accent1"/>
+          </a:lnRef>
+          <a:fillRef idx="3">
+            <a:schemeClr val="accent1"/>
+          </a:fillRef>
+          <a:effectRef idx="2">
+            <a:schemeClr val="accent1"/>
+          </a:effectRef>
+          <a:fontRef idx="minor">
+            <a:schemeClr val="lt1"/>
+          </a:fontRef>
+        </p:style>
+        <p:txBody>
+          <a:bodyPr rtlCol="0" anchor="ctr"/>
+          <a:lstStyle/>
+          <a:p>
+            <a:pPr algn="ctr"/>
+          </a:p>
+        </p:txBody>
+      </p:sp>
+      <p:sp>
+        <p:nvSpPr>
+          <p:cNvPr id="22" name="Rectangle 21"/>
+          <p:cNvSpPr/>
+          <p:nvPr/>
+        </p:nvSpPr>
+        <p:spPr>
+          <a:xfrm>
+            <a:off x="6858000" y="5722620"/>
+            <a:ext cx="164592" cy="38100"/>
+          </a:xfrm>
+          <a:prstGeom prst="rect">
+            <a:avLst/>
+          </a:prstGeom>
+          <a:solidFill>
+            <a:srgbClr val="4DA3FF"/>
+          </a:solidFill>
+          <a:ln>
+            <a:noFill/>
+          </a:ln>
+        </p:spPr>
+        <p:style>
+          <a:lnRef idx="1">
+            <a:schemeClr val="accent1"/>
+          </a:lnRef>
+          <a:fillRef idx="3">
+            <a:schemeClr val="accent1"/>
+          </a:fillRef>
+          <a:effectRef idx="2">
+            <a:schemeClr val="accent1"/>
+          </a:effectRef>
+          <a:fontRef idx="minor">
+            <a:schemeClr val="lt1"/>
+          </a:fontRef>
+        </p:style>
+        <p:txBody>
+          <a:bodyPr rtlCol="0" anchor="ctr"/>
+          <a:lstStyle/>
+          <a:p>
+            <a:pPr algn="ctr"/>
+          </a:p>
+        </p:txBody>
+      </p:sp>
+      <p:sp>
+        <p:nvSpPr>
+          <p:cNvPr id="23" name="Rectangle 22"/>
+          <p:cNvSpPr/>
+          <p:nvPr/>
+        </p:nvSpPr>
+        <p:spPr>
+          <a:xfrm>
+            <a:off x="6858000" y="5596128"/>
+            <a:ext cx="38100" cy="164592"/>
+          </a:xfrm>
+          <a:prstGeom prst="rect">
+            <a:avLst/>
+          </a:prstGeom>
+          <a:solidFill>
+            <a:srgbClr val="4DA3FF"/>
+          </a:solidFill>
+          <a:ln>
+            <a:noFill/>
+          </a:ln>
+        </p:spPr>
+        <p:style>
+          <a:lnRef idx="1">
+            <a:schemeClr val="accent1"/>
+          </a:lnRef>
+          <a:fillRef idx="3">
+            <a:schemeClr val="accent1"/>
+          </a:fillRef>
+          <a:effectRef idx="2">
+            <a:schemeClr val="accent1"/>
+          </a:effectRef>
+          <a:fontRef idx="minor">
+            <a:schemeClr val="lt1"/>
+          </a:fontRef>
+        </p:style>
+        <p:txBody>
+          <a:bodyPr rtlCol="0" anchor="ctr"/>
+          <a:lstStyle/>
+          <a:p>
+            <a:pPr algn="ctr"/>
+          </a:p>
+        </p:txBody>
+      </p:sp>
+      <p:sp>
+        <p:nvSpPr>
+          <p:cNvPr id="24" name="Rectangle 23"/>
+          <p:cNvSpPr/>
+          <p:nvPr/>
+        </p:nvSpPr>
+        <p:spPr>
+          <a:xfrm>
+            <a:off x="11265408" y="5722620"/>
+            <a:ext cx="164592" cy="38100"/>
+          </a:xfrm>
+          <a:prstGeom prst="rect">
+            <a:avLst/>
+          </a:prstGeom>
+          <a:solidFill>
+            <a:srgbClr val="4DA3FF"/>
+          </a:solidFill>
+          <a:ln>
+            <a:noFill/>
+          </a:ln>
+        </p:spPr>
+        <p:style>
+          <a:lnRef idx="1">
+            <a:schemeClr val="accent1"/>
+          </a:lnRef>
+          <a:fillRef idx="3">
+            <a:schemeClr val="accent1"/>
+          </a:fillRef>
+          <a:effectRef idx="2">
+            <a:schemeClr val="accent1"/>
+          </a:effectRef>
+          <a:fontRef idx="minor">
+            <a:schemeClr val="lt1"/>
+          </a:fontRef>
+        </p:style>
+        <p:txBody>
+          <a:bodyPr rtlCol="0" anchor="ctr"/>
+          <a:lstStyle/>
+          <a:p>
+            <a:pPr algn="ctr"/>
+          </a:p>
+        </p:txBody>
+      </p:sp>
+      <p:sp>
+        <p:nvSpPr>
+          <p:cNvPr id="25" name="Rectangle 24"/>
+          <p:cNvSpPr/>
+          <p:nvPr/>
+        </p:nvSpPr>
+        <p:spPr>
+          <a:xfrm>
+            <a:off x="11391900" y="5596128"/>
+            <a:ext cx="38100" cy="164592"/>
+          </a:xfrm>
+          <a:prstGeom prst="rect">
+            <a:avLst/>
+          </a:prstGeom>
+          <a:solidFill>
+            <a:srgbClr val="4DA3FF"/>
+          </a:solidFill>
+          <a:ln>
+            <a:noFill/>
+          </a:ln>
+        </p:spPr>
+        <p:style>
+          <a:lnRef idx="1">
+            <a:schemeClr val="accent1"/>
+          </a:lnRef>
+          <a:fillRef idx="3">
+            <a:schemeClr val="accent1"/>
+          </a:fillRef>
+          <a:effectRef idx="2">
+            <a:schemeClr val="accent1"/>
+          </a:effectRef>
+          <a:fontRef idx="minor">
+            <a:schemeClr val="lt1"/>
+          </a:fontRef>
+        </p:style>
+        <p:txBody>
+          <a:bodyPr rtlCol="0" anchor="ctr"/>
+          <a:lstStyle/>
+          <a:p>
+            <a:pPr algn="ctr"/>
+          </a:p>
+        </p:txBody>
+      </p:sp>
+      <p:sp>
+        <p:nvSpPr>
+          <p:cNvPr id="26" name="Rectangle 25"/>
+          <p:cNvSpPr/>
+          <p:nvPr/>
+        </p:nvSpPr>
+        <p:spPr>
+          <a:xfrm>
+            <a:off x="6995160" y="1874519"/>
             <a:ext cx="1828800" cy="365760"/>
           </a:xfrm>
-          <a:prstGeom prst="roundRect">
+          <a:prstGeom prst="rect">
             <a:avLst/>
           </a:prstGeom>
           <a:solidFill>
@@ -7427,13 +8201,13 @@
       </p:sp>
       <p:sp>
         <p:nvSpPr>
-          <p:cNvPr id="18" name="TextBox 17"/>
+          <p:cNvPr id="27" name="TextBox 26"/>
           <p:cNvSpPr txBox="1"/>
           <p:nvPr/>
         </p:nvSpPr>
         <p:spPr>
           <a:xfrm>
-            <a:off x="7040880" y="1920240"/>
+            <a:off x="6995160" y="1874519"/>
             <a:ext cx="1828800" cy="365760"/>
           </a:xfrm>
           <a:prstGeom prst="rect">
@@ -7463,7 +8237,88 @@
       </p:sp>
       <p:sp>
         <p:nvSpPr>
-          <p:cNvPr id="19" name="Rounded Rectangle 18"/>
+          <p:cNvPr id="28" name="Rectangle 27"/>
+          <p:cNvSpPr/>
+          <p:nvPr/>
+        </p:nvSpPr>
+        <p:spPr>
+          <a:xfrm>
+            <a:off x="6858000" y="5760720"/>
+            <a:ext cx="4572000" cy="457200"/>
+          </a:xfrm>
+          <a:prstGeom prst="rect">
+            <a:avLst/>
+          </a:prstGeom>
+          <a:solidFill>
+            <a:srgbClr val="3C0F0F"/>
+          </a:solidFill>
+          <a:ln w="12700">
+            <a:solidFill>
+              <a:srgbClr val="FF5A5A"/>
+            </a:solidFill>
+          </a:ln>
+        </p:spPr>
+        <p:style>
+          <a:lnRef idx="1">
+            <a:schemeClr val="accent1"/>
+          </a:lnRef>
+          <a:fillRef idx="3">
+            <a:schemeClr val="accent1"/>
+          </a:fillRef>
+          <a:effectRef idx="2">
+            <a:schemeClr val="accent1"/>
+          </a:effectRef>
+          <a:fontRef idx="minor">
+            <a:schemeClr val="lt1"/>
+          </a:fontRef>
+        </p:style>
+        <p:txBody>
+          <a:bodyPr rtlCol="0" anchor="ctr"/>
+          <a:lstStyle/>
+          <a:p>
+            <a:pPr algn="ctr"/>
+          </a:p>
+        </p:txBody>
+      </p:sp>
+      <p:sp>
+        <p:nvSpPr>
+          <p:cNvPr id="29" name="TextBox 28"/>
+          <p:cNvSpPr txBox="1"/>
+          <p:nvPr/>
+        </p:nvSpPr>
+        <p:spPr>
+          <a:xfrm>
+            <a:off x="6858000" y="5760720"/>
+            <a:ext cx="4572000" cy="457200"/>
+          </a:xfrm>
+          <a:prstGeom prst="rect">
+            <a:avLst/>
+          </a:prstGeom>
+          <a:noFill/>
+        </p:spPr>
+        <p:txBody>
+          <a:bodyPr wrap="square">
+            <a:spAutoFit/>
+          </a:bodyPr>
+          <a:lstStyle/>
+          <a:p>
+            <a:pPr algn="ctr">
+              <a:defRPr sz="900" b="0">
+                <a:solidFill>
+                  <a:srgbClr val="FF9696"/>
+                </a:solidFill>
+                <a:latin typeface="Calibri"/>
+              </a:defRPr>
+            </a:pPr>
+            <a:r>
+              <a:t>🔍  Thermal Imaging: Pressure Drop 7.2 → 5.8 bar</a:t>
+            </a:r>
+          </a:p>
+        </p:txBody>
+      </p:sp>
+      <p:sp>
+        <p:nvSpPr>
+          <p:cNvPr id="30" name="Rectangle 29"/>
           <p:cNvSpPr/>
           <p:nvPr/>
         </p:nvSpPr>
@@ -7472,7 +8327,7 @@
             <a:off x="731520" y="1737360"/>
             <a:ext cx="2743200" cy="2103120"/>
           </a:xfrm>
-          <a:prstGeom prst="roundRect">
+          <a:prstGeom prst="rect">
             <a:avLst/>
           </a:prstGeom>
           <a:solidFill>
@@ -7508,14 +8363,14 @@
       </p:sp>
       <p:sp>
         <p:nvSpPr>
-          <p:cNvPr id="20" name="Rectangle 19"/>
-          <p:cNvSpPr/>
-          <p:nvPr/>
-        </p:nvSpPr>
-        <p:spPr>
-          <a:xfrm>
-            <a:off x="914400" y="1920240"/>
-            <a:ext cx="548640" cy="38100"/>
+          <p:cNvPr id="31" name="Rectangle 30"/>
+          <p:cNvSpPr/>
+          <p:nvPr/>
+        </p:nvSpPr>
+        <p:spPr>
+          <a:xfrm>
+            <a:off x="731520" y="1737360"/>
+            <a:ext cx="2743200" cy="38100"/>
           </a:xfrm>
           <a:prstGeom prst="rect">
             <a:avLst/>
@@ -7551,16 +8406,16 @@
       </p:sp>
       <p:sp>
         <p:nvSpPr>
-          <p:cNvPr id="21" name="Rounded Rectangle 20"/>
-          <p:cNvSpPr/>
-          <p:nvPr/>
-        </p:nvSpPr>
-        <p:spPr>
-          <a:xfrm>
-            <a:off x="2560320" y="1920240"/>
+          <p:cNvPr id="32" name="Rectangle 31"/>
+          <p:cNvSpPr/>
+          <p:nvPr/>
+        </p:nvSpPr>
+        <p:spPr>
+          <a:xfrm>
+            <a:off x="2560320" y="1874520"/>
             <a:ext cx="640080" cy="274320"/>
           </a:xfrm>
-          <a:prstGeom prst="roundRect">
+          <a:prstGeom prst="rect">
             <a:avLst/>
           </a:prstGeom>
           <a:solidFill>
@@ -7596,13 +8451,13 @@
       </p:sp>
       <p:sp>
         <p:nvSpPr>
-          <p:cNvPr id="22" name="TextBox 21"/>
+          <p:cNvPr id="33" name="TextBox 32"/>
           <p:cNvSpPr txBox="1"/>
           <p:nvPr/>
         </p:nvSpPr>
         <p:spPr>
           <a:xfrm>
-            <a:off x="2560320" y="1920240"/>
+            <a:off x="2560320" y="1874520"/>
             <a:ext cx="640080" cy="274320"/>
           </a:xfrm>
           <a:prstGeom prst="rect">
@@ -7632,13 +8487,13 @@
       </p:sp>
       <p:sp>
         <p:nvSpPr>
-          <p:cNvPr id="23" name="TextBox 22"/>
+          <p:cNvPr id="34" name="TextBox 33"/>
           <p:cNvSpPr txBox="1"/>
           <p:nvPr/>
         </p:nvSpPr>
         <p:spPr>
           <a:xfrm>
-            <a:off x="914400" y="2240280"/>
+            <a:off x="914400" y="2194560"/>
             <a:ext cx="2377440" cy="365760"/>
           </a:xfrm>
           <a:prstGeom prst="rect">
@@ -7668,13 +8523,13 @@
       </p:sp>
       <p:sp>
         <p:nvSpPr>
-          <p:cNvPr id="24" name="TextBox 23"/>
+          <p:cNvPr id="35" name="TextBox 34"/>
           <p:cNvSpPr txBox="1"/>
           <p:nvPr/>
         </p:nvSpPr>
         <p:spPr>
           <a:xfrm>
-            <a:off x="914400" y="2651760"/>
+            <a:off x="914400" y="2560320"/>
             <a:ext cx="2377440" cy="914400"/>
           </a:xfrm>
           <a:prstGeom prst="rect">
@@ -7708,13 +8563,13 @@
       </p:sp>
       <p:sp>
         <p:nvSpPr>
-          <p:cNvPr id="25" name="TextBox 24"/>
+          <p:cNvPr id="36" name="TextBox 35"/>
           <p:cNvSpPr txBox="1"/>
           <p:nvPr/>
         </p:nvSpPr>
         <p:spPr>
           <a:xfrm>
-            <a:off x="914400" y="3383280"/>
+            <a:off x="914400" y="3429000"/>
             <a:ext cx="2377440" cy="274320"/>
           </a:xfrm>
           <a:prstGeom prst="rect">
@@ -7744,7 +8599,7 @@
       </p:sp>
       <p:sp>
         <p:nvSpPr>
-          <p:cNvPr id="26" name="Rounded Rectangle 25"/>
+          <p:cNvPr id="37" name="Rectangle 36"/>
           <p:cNvSpPr/>
           <p:nvPr/>
         </p:nvSpPr>
@@ -7753,7 +8608,7 @@
             <a:off x="3657600" y="1737360"/>
             <a:ext cx="2743200" cy="2103120"/>
           </a:xfrm>
-          <a:prstGeom prst="roundRect">
+          <a:prstGeom prst="rect">
             <a:avLst/>
           </a:prstGeom>
           <a:solidFill>
@@ -7789,14 +8644,14 @@
       </p:sp>
       <p:sp>
         <p:nvSpPr>
-          <p:cNvPr id="27" name="Rectangle 26"/>
-          <p:cNvSpPr/>
-          <p:nvPr/>
-        </p:nvSpPr>
-        <p:spPr>
-          <a:xfrm>
-            <a:off x="3840480" y="1920240"/>
-            <a:ext cx="548640" cy="38100"/>
+          <p:cNvPr id="38" name="Rectangle 37"/>
+          <p:cNvSpPr/>
+          <p:nvPr/>
+        </p:nvSpPr>
+        <p:spPr>
+          <a:xfrm>
+            <a:off x="3657600" y="1737360"/>
+            <a:ext cx="2743200" cy="38100"/>
           </a:xfrm>
           <a:prstGeom prst="rect">
             <a:avLst/>
@@ -7832,16 +8687,16 @@
       </p:sp>
       <p:sp>
         <p:nvSpPr>
-          <p:cNvPr id="28" name="Rounded Rectangle 27"/>
-          <p:cNvSpPr/>
-          <p:nvPr/>
-        </p:nvSpPr>
-        <p:spPr>
-          <a:xfrm>
-            <a:off x="5486400" y="1920240"/>
+          <p:cNvPr id="39" name="Rectangle 38"/>
+          <p:cNvSpPr/>
+          <p:nvPr/>
+        </p:nvSpPr>
+        <p:spPr>
+          <a:xfrm>
+            <a:off x="5486400" y="1874520"/>
             <a:ext cx="640080" cy="274320"/>
           </a:xfrm>
-          <a:prstGeom prst="roundRect">
+          <a:prstGeom prst="rect">
             <a:avLst/>
           </a:prstGeom>
           <a:solidFill>
@@ -7877,13 +8732,13 @@
       </p:sp>
       <p:sp>
         <p:nvSpPr>
-          <p:cNvPr id="29" name="TextBox 28"/>
+          <p:cNvPr id="40" name="TextBox 39"/>
           <p:cNvSpPr txBox="1"/>
           <p:nvPr/>
         </p:nvSpPr>
         <p:spPr>
           <a:xfrm>
-            <a:off x="5486400" y="1920240"/>
+            <a:off x="5486400" y="1874520"/>
             <a:ext cx="640080" cy="274320"/>
           </a:xfrm>
           <a:prstGeom prst="rect">
@@ -7913,13 +8768,13 @@
       </p:sp>
       <p:sp>
         <p:nvSpPr>
-          <p:cNvPr id="30" name="TextBox 29"/>
+          <p:cNvPr id="41" name="TextBox 40"/>
           <p:cNvSpPr txBox="1"/>
           <p:nvPr/>
         </p:nvSpPr>
         <p:spPr>
           <a:xfrm>
-            <a:off x="3840480" y="2240280"/>
+            <a:off x="3840480" y="2194560"/>
             <a:ext cx="2377440" cy="365760"/>
           </a:xfrm>
           <a:prstGeom prst="rect">
@@ -7949,13 +8804,13 @@
       </p:sp>
       <p:sp>
         <p:nvSpPr>
-          <p:cNvPr id="31" name="TextBox 30"/>
+          <p:cNvPr id="42" name="TextBox 41"/>
           <p:cNvSpPr txBox="1"/>
           <p:nvPr/>
         </p:nvSpPr>
         <p:spPr>
           <a:xfrm>
-            <a:off x="3840480" y="2651760"/>
+            <a:off x="3840480" y="2560320"/>
             <a:ext cx="2377440" cy="914400"/>
           </a:xfrm>
           <a:prstGeom prst="rect">
@@ -7989,13 +8844,13 @@
       </p:sp>
       <p:sp>
         <p:nvSpPr>
-          <p:cNvPr id="32" name="TextBox 31"/>
+          <p:cNvPr id="43" name="TextBox 42"/>
           <p:cNvSpPr txBox="1"/>
           <p:nvPr/>
         </p:nvSpPr>
         <p:spPr>
           <a:xfrm>
-            <a:off x="3840480" y="3383280"/>
+            <a:off x="3840480" y="3429000"/>
             <a:ext cx="2377440" cy="274320"/>
           </a:xfrm>
           <a:prstGeom prst="rect">
@@ -8025,7 +8880,7 @@
       </p:sp>
       <p:sp>
         <p:nvSpPr>
-          <p:cNvPr id="33" name="Rounded Rectangle 32"/>
+          <p:cNvPr id="44" name="Rectangle 43"/>
           <p:cNvSpPr/>
           <p:nvPr/>
         </p:nvSpPr>
@@ -8034,7 +8889,7 @@
             <a:off x="731520" y="4114800"/>
             <a:ext cx="2743200" cy="2103120"/>
           </a:xfrm>
-          <a:prstGeom prst="roundRect">
+          <a:prstGeom prst="rect">
             <a:avLst/>
           </a:prstGeom>
           <a:solidFill>
@@ -8070,14 +8925,14 @@
       </p:sp>
       <p:sp>
         <p:nvSpPr>
-          <p:cNvPr id="34" name="Rectangle 33"/>
-          <p:cNvSpPr/>
-          <p:nvPr/>
-        </p:nvSpPr>
-        <p:spPr>
-          <a:xfrm>
-            <a:off x="914400" y="4297680"/>
-            <a:ext cx="548640" cy="38100"/>
+          <p:cNvPr id="45" name="Rectangle 44"/>
+          <p:cNvSpPr/>
+          <p:nvPr/>
+        </p:nvSpPr>
+        <p:spPr>
+          <a:xfrm>
+            <a:off x="731520" y="4114800"/>
+            <a:ext cx="2743200" cy="38100"/>
           </a:xfrm>
           <a:prstGeom prst="rect">
             <a:avLst/>
@@ -8113,16 +8968,16 @@
       </p:sp>
       <p:sp>
         <p:nvSpPr>
-          <p:cNvPr id="35" name="Rounded Rectangle 34"/>
-          <p:cNvSpPr/>
-          <p:nvPr/>
-        </p:nvSpPr>
-        <p:spPr>
-          <a:xfrm>
-            <a:off x="2560320" y="4297680"/>
+          <p:cNvPr id="46" name="Rectangle 45"/>
+          <p:cNvSpPr/>
+          <p:nvPr/>
+        </p:nvSpPr>
+        <p:spPr>
+          <a:xfrm>
+            <a:off x="2560320" y="4251960"/>
             <a:ext cx="640080" cy="274320"/>
           </a:xfrm>
-          <a:prstGeom prst="roundRect">
+          <a:prstGeom prst="rect">
             <a:avLst/>
           </a:prstGeom>
           <a:solidFill>
@@ -8158,13 +9013,13 @@
       </p:sp>
       <p:sp>
         <p:nvSpPr>
-          <p:cNvPr id="36" name="TextBox 35"/>
+          <p:cNvPr id="47" name="TextBox 46"/>
           <p:cNvSpPr txBox="1"/>
           <p:nvPr/>
         </p:nvSpPr>
         <p:spPr>
           <a:xfrm>
-            <a:off x="2560320" y="4297680"/>
+            <a:off x="2560320" y="4251960"/>
             <a:ext cx="640080" cy="274320"/>
           </a:xfrm>
           <a:prstGeom prst="rect">
@@ -8194,13 +9049,13 @@
       </p:sp>
       <p:sp>
         <p:nvSpPr>
-          <p:cNvPr id="37" name="TextBox 36"/>
+          <p:cNvPr id="48" name="TextBox 47"/>
           <p:cNvSpPr txBox="1"/>
           <p:nvPr/>
         </p:nvSpPr>
         <p:spPr>
           <a:xfrm>
-            <a:off x="914400" y="4617720"/>
+            <a:off x="914400" y="4572000"/>
             <a:ext cx="2377440" cy="365760"/>
           </a:xfrm>
           <a:prstGeom prst="rect">
@@ -8230,13 +9085,13 @@
       </p:sp>
       <p:sp>
         <p:nvSpPr>
-          <p:cNvPr id="38" name="TextBox 37"/>
+          <p:cNvPr id="49" name="TextBox 48"/>
           <p:cNvSpPr txBox="1"/>
           <p:nvPr/>
         </p:nvSpPr>
         <p:spPr>
           <a:xfrm>
-            <a:off x="914400" y="5029200"/>
+            <a:off x="914400" y="4937760"/>
             <a:ext cx="2377440" cy="914400"/>
           </a:xfrm>
           <a:prstGeom prst="rect">
@@ -8270,13 +9125,13 @@
       </p:sp>
       <p:sp>
         <p:nvSpPr>
-          <p:cNvPr id="39" name="TextBox 38"/>
+          <p:cNvPr id="50" name="TextBox 49"/>
           <p:cNvSpPr txBox="1"/>
           <p:nvPr/>
         </p:nvSpPr>
         <p:spPr>
           <a:xfrm>
-            <a:off x="914400" y="5760720"/>
+            <a:off x="914400" y="5806440"/>
             <a:ext cx="2377440" cy="274320"/>
           </a:xfrm>
           <a:prstGeom prst="rect">
@@ -8306,7 +9161,7 @@
       </p:sp>
       <p:sp>
         <p:nvSpPr>
-          <p:cNvPr id="40" name="Rounded Rectangle 39"/>
+          <p:cNvPr id="51" name="Rectangle 50"/>
           <p:cNvSpPr/>
           <p:nvPr/>
         </p:nvSpPr>
@@ -8315,7 +9170,7 @@
             <a:off x="3657600" y="4114800"/>
             <a:ext cx="2743200" cy="2103120"/>
           </a:xfrm>
-          <a:prstGeom prst="roundRect">
+          <a:prstGeom prst="rect">
             <a:avLst/>
           </a:prstGeom>
           <a:solidFill>
@@ -8351,14 +9206,14 @@
       </p:sp>
       <p:sp>
         <p:nvSpPr>
-          <p:cNvPr id="41" name="Rectangle 40"/>
-          <p:cNvSpPr/>
-          <p:nvPr/>
-        </p:nvSpPr>
-        <p:spPr>
-          <a:xfrm>
-            <a:off x="3840480" y="4297680"/>
-            <a:ext cx="548640" cy="38100"/>
+          <p:cNvPr id="52" name="Rectangle 51"/>
+          <p:cNvSpPr/>
+          <p:nvPr/>
+        </p:nvSpPr>
+        <p:spPr>
+          <a:xfrm>
+            <a:off x="3657600" y="4114800"/>
+            <a:ext cx="2743200" cy="38100"/>
           </a:xfrm>
           <a:prstGeom prst="rect">
             <a:avLst/>
@@ -8394,16 +9249,16 @@
       </p:sp>
       <p:sp>
         <p:nvSpPr>
-          <p:cNvPr id="42" name="Rounded Rectangle 41"/>
-          <p:cNvSpPr/>
-          <p:nvPr/>
-        </p:nvSpPr>
-        <p:spPr>
-          <a:xfrm>
-            <a:off x="5486400" y="4297680"/>
+          <p:cNvPr id="53" name="Rectangle 52"/>
+          <p:cNvSpPr/>
+          <p:nvPr/>
+        </p:nvSpPr>
+        <p:spPr>
+          <a:xfrm>
+            <a:off x="5486400" y="4251960"/>
             <a:ext cx="640080" cy="274320"/>
           </a:xfrm>
-          <a:prstGeom prst="roundRect">
+          <a:prstGeom prst="rect">
             <a:avLst/>
           </a:prstGeom>
           <a:solidFill>
@@ -8439,13 +9294,13 @@
       </p:sp>
       <p:sp>
         <p:nvSpPr>
-          <p:cNvPr id="43" name="TextBox 42"/>
+          <p:cNvPr id="54" name="TextBox 53"/>
           <p:cNvSpPr txBox="1"/>
           <p:nvPr/>
         </p:nvSpPr>
         <p:spPr>
           <a:xfrm>
-            <a:off x="5486400" y="4297680"/>
+            <a:off x="5486400" y="4251960"/>
             <a:ext cx="640080" cy="274320"/>
           </a:xfrm>
           <a:prstGeom prst="rect">
@@ -8475,13 +9330,13 @@
       </p:sp>
       <p:sp>
         <p:nvSpPr>
-          <p:cNvPr id="44" name="TextBox 43"/>
+          <p:cNvPr id="55" name="TextBox 54"/>
           <p:cNvSpPr txBox="1"/>
           <p:nvPr/>
         </p:nvSpPr>
         <p:spPr>
           <a:xfrm>
-            <a:off x="3840480" y="4617720"/>
+            <a:off x="3840480" y="4572000"/>
             <a:ext cx="2377440" cy="365760"/>
           </a:xfrm>
           <a:prstGeom prst="rect">
@@ -8511,13 +9366,13 @@
       </p:sp>
       <p:sp>
         <p:nvSpPr>
-          <p:cNvPr id="45" name="TextBox 44"/>
+          <p:cNvPr id="56" name="TextBox 55"/>
           <p:cNvSpPr txBox="1"/>
           <p:nvPr/>
         </p:nvSpPr>
         <p:spPr>
           <a:xfrm>
-            <a:off x="3840480" y="5029200"/>
+            <a:off x="3840480" y="4937760"/>
             <a:ext cx="2377440" cy="914400"/>
           </a:xfrm>
           <a:prstGeom prst="rect">
@@ -8551,13 +9406,13 @@
       </p:sp>
       <p:sp>
         <p:nvSpPr>
-          <p:cNvPr id="46" name="TextBox 45"/>
+          <p:cNvPr id="57" name="TextBox 56"/>
           <p:cNvSpPr txBox="1"/>
           <p:nvPr/>
         </p:nvSpPr>
         <p:spPr>
           <a:xfrm>
-            <a:off x="3840480" y="5760720"/>
+            <a:off x="3840480" y="5806440"/>
             <a:ext cx="2377440" cy="274320"/>
           </a:xfrm>
           <a:prstGeom prst="rect">
@@ -8587,7 +9442,7 @@
       </p:sp>
       <p:sp>
         <p:nvSpPr>
-          <p:cNvPr id="47" name="Oval 46"/>
+          <p:cNvPr id="58" name="Oval 57"/>
           <p:cNvSpPr/>
           <p:nvPr/>
         </p:nvSpPr>
@@ -8630,7 +9485,7 @@
       </p:sp>
       <p:sp>
         <p:nvSpPr>
-          <p:cNvPr id="48" name="Oval 47"/>
+          <p:cNvPr id="59" name="Oval 58"/>
           <p:cNvSpPr/>
           <p:nvPr/>
         </p:nvSpPr>
@@ -8673,7 +9528,7 @@
       </p:sp>
       <p:sp>
         <p:nvSpPr>
-          <p:cNvPr id="49" name="Oval 48"/>
+          <p:cNvPr id="60" name="Oval 59"/>
           <p:cNvSpPr/>
           <p:nvPr/>
         </p:nvSpPr>
@@ -8716,7 +9571,7 @@
       </p:sp>
       <p:sp>
         <p:nvSpPr>
-          <p:cNvPr id="50" name="Oval 49"/>
+          <p:cNvPr id="61" name="Oval 60"/>
           <p:cNvSpPr/>
           <p:nvPr/>
         </p:nvSpPr>
@@ -8759,7 +9614,7 @@
       </p:sp>
       <p:sp>
         <p:nvSpPr>
-          <p:cNvPr id="51" name="Oval 50"/>
+          <p:cNvPr id="62" name="Oval 61"/>
           <p:cNvSpPr/>
           <p:nvPr/>
         </p:nvSpPr>
@@ -8802,7 +9657,7 @@
       </p:sp>
       <p:sp>
         <p:nvSpPr>
-          <p:cNvPr id="52" name="Oval 51"/>
+          <p:cNvPr id="63" name="Oval 62"/>
           <p:cNvSpPr/>
           <p:nvPr/>
         </p:nvSpPr>
@@ -8845,7 +9700,7 @@
       </p:sp>
       <p:sp>
         <p:nvSpPr>
-          <p:cNvPr id="53" name="Oval 52"/>
+          <p:cNvPr id="64" name="Oval 63"/>
           <p:cNvSpPr/>
           <p:nvPr/>
         </p:nvSpPr>
@@ -8888,7 +9743,7 @@
       </p:sp>
       <p:sp>
         <p:nvSpPr>
-          <p:cNvPr id="54" name="Oval 53"/>
+          <p:cNvPr id="65" name="Oval 64"/>
           <p:cNvSpPr/>
           <p:nvPr/>
         </p:nvSpPr>
@@ -8931,7 +9786,7 @@
       </p:sp>
       <p:sp>
         <p:nvSpPr>
-          <p:cNvPr id="55" name="Oval 54"/>
+          <p:cNvPr id="66" name="Oval 65"/>
           <p:cNvSpPr/>
           <p:nvPr/>
         </p:nvSpPr>
@@ -8974,7 +9829,7 @@
       </p:sp>
       <p:sp>
         <p:nvSpPr>
-          <p:cNvPr id="56" name="Oval 55"/>
+          <p:cNvPr id="67" name="Oval 66"/>
           <p:cNvSpPr/>
           <p:nvPr/>
         </p:nvSpPr>
@@ -9017,7 +9872,7 @@
       </p:sp>
       <p:sp>
         <p:nvSpPr>
-          <p:cNvPr id="57" name="Oval 56"/>
+          <p:cNvPr id="68" name="Oval 67"/>
           <p:cNvSpPr/>
           <p:nvPr/>
         </p:nvSpPr>
@@ -9060,7 +9915,7 @@
       </p:sp>
       <p:sp>
         <p:nvSpPr>
-          <p:cNvPr id="58" name="Oval 57"/>
+          <p:cNvPr id="69" name="Oval 68"/>
           <p:cNvSpPr/>
           <p:nvPr/>
         </p:nvSpPr>
@@ -9669,22 +10524,22 @@
       </p:sp>
       <p:sp>
         <p:nvSpPr>
-          <p:cNvPr id="15" name="Rounded Rectangle 14"/>
-          <p:cNvSpPr/>
-          <p:nvPr/>
-        </p:nvSpPr>
-        <p:spPr>
-          <a:xfrm>
-            <a:off x="680720" y="1686560"/>
-            <a:ext cx="4673600" cy="4673600"/>
-          </a:xfrm>
-          <a:prstGeom prst="roundRect">
-            <a:avLst/>
-          </a:prstGeom>
-          <a:solidFill>
-            <a:srgbClr val="111B37"/>
-          </a:solidFill>
-          <a:ln w="19050">
+          <p:cNvPr id="15" name="Rectangle 14"/>
+          <p:cNvSpPr/>
+          <p:nvPr/>
+        </p:nvSpPr>
+        <p:spPr>
+          <a:xfrm>
+            <a:off x="731520" y="1737360"/>
+            <a:ext cx="4572000" cy="4023360"/>
+          </a:xfrm>
+          <a:prstGeom prst="rect">
+            <a:avLst/>
+          </a:prstGeom>
+          <a:solidFill>
+            <a:srgbClr val="0C142D"/>
+          </a:solidFill>
+          <a:ln w="22860">
             <a:solidFill>
               <a:srgbClr val="4DA3FF"/>
             </a:solidFill>
@@ -9728,32 +10583,419 @@
         </p:blipFill>
         <p:spPr>
           <a:xfrm>
+            <a:off x="763524" y="1769364"/>
+            <a:ext cx="4507992" cy="3959352"/>
+          </a:xfrm>
+          <a:prstGeom prst="rect">
+            <a:avLst/>
+          </a:prstGeom>
+        </p:spPr>
+      </p:pic>
+      <p:sp>
+        <p:nvSpPr>
+          <p:cNvPr id="17" name="Rectangle 16"/>
+          <p:cNvSpPr/>
+          <p:nvPr/>
+        </p:nvSpPr>
+        <p:spPr>
+          <a:xfrm>
             <a:off x="731520" y="1737360"/>
-            <a:ext cx="4572000" cy="4572000"/>
-          </a:xfrm>
-          <a:prstGeom prst="rect">
-            <a:avLst/>
-          </a:prstGeom>
-        </p:spPr>
-      </p:pic>
-      <p:sp>
-        <p:nvSpPr>
-          <p:cNvPr id="17" name="Rounded Rectangle 16"/>
-          <p:cNvSpPr/>
-          <p:nvPr/>
-        </p:nvSpPr>
-        <p:spPr>
-          <a:xfrm>
-            <a:off x="914400" y="5669280"/>
-            <a:ext cx="4206240" cy="457200"/>
-          </a:xfrm>
-          <a:prstGeom prst="roundRect">
+            <a:ext cx="4572000" cy="38100"/>
+          </a:xfrm>
+          <a:prstGeom prst="rect">
+            <a:avLst/>
+          </a:prstGeom>
+          <a:solidFill>
+            <a:srgbClr val="4DA3FF"/>
+          </a:solidFill>
+          <a:ln>
+            <a:noFill/>
+          </a:ln>
+        </p:spPr>
+        <p:style>
+          <a:lnRef idx="1">
+            <a:schemeClr val="accent1"/>
+          </a:lnRef>
+          <a:fillRef idx="3">
+            <a:schemeClr val="accent1"/>
+          </a:fillRef>
+          <a:effectRef idx="2">
+            <a:schemeClr val="accent1"/>
+          </a:effectRef>
+          <a:fontRef idx="minor">
+            <a:schemeClr val="lt1"/>
+          </a:fontRef>
+        </p:style>
+        <p:txBody>
+          <a:bodyPr rtlCol="0" anchor="ctr"/>
+          <a:lstStyle/>
+          <a:p>
+            <a:pPr algn="ctr"/>
+          </a:p>
+        </p:txBody>
+      </p:sp>
+      <p:sp>
+        <p:nvSpPr>
+          <p:cNvPr id="18" name="Rectangle 17"/>
+          <p:cNvSpPr/>
+          <p:nvPr/>
+        </p:nvSpPr>
+        <p:spPr>
+          <a:xfrm>
+            <a:off x="731520" y="1737360"/>
+            <a:ext cx="164592" cy="38100"/>
+          </a:xfrm>
+          <a:prstGeom prst="rect">
+            <a:avLst/>
+          </a:prstGeom>
+          <a:solidFill>
+            <a:srgbClr val="00D4FF"/>
+          </a:solidFill>
+          <a:ln>
+            <a:noFill/>
+          </a:ln>
+        </p:spPr>
+        <p:style>
+          <a:lnRef idx="1">
+            <a:schemeClr val="accent1"/>
+          </a:lnRef>
+          <a:fillRef idx="3">
+            <a:schemeClr val="accent1"/>
+          </a:fillRef>
+          <a:effectRef idx="2">
+            <a:schemeClr val="accent1"/>
+          </a:effectRef>
+          <a:fontRef idx="minor">
+            <a:schemeClr val="lt1"/>
+          </a:fontRef>
+        </p:style>
+        <p:txBody>
+          <a:bodyPr rtlCol="0" anchor="ctr"/>
+          <a:lstStyle/>
+          <a:p>
+            <a:pPr algn="ctr"/>
+          </a:p>
+        </p:txBody>
+      </p:sp>
+      <p:sp>
+        <p:nvSpPr>
+          <p:cNvPr id="19" name="Rectangle 18"/>
+          <p:cNvSpPr/>
+          <p:nvPr/>
+        </p:nvSpPr>
+        <p:spPr>
+          <a:xfrm>
+            <a:off x="731520" y="1737360"/>
+            <a:ext cx="38100" cy="164592"/>
+          </a:xfrm>
+          <a:prstGeom prst="rect">
+            <a:avLst/>
+          </a:prstGeom>
+          <a:solidFill>
+            <a:srgbClr val="00D4FF"/>
+          </a:solidFill>
+          <a:ln>
+            <a:noFill/>
+          </a:ln>
+        </p:spPr>
+        <p:style>
+          <a:lnRef idx="1">
+            <a:schemeClr val="accent1"/>
+          </a:lnRef>
+          <a:fillRef idx="3">
+            <a:schemeClr val="accent1"/>
+          </a:fillRef>
+          <a:effectRef idx="2">
+            <a:schemeClr val="accent1"/>
+          </a:effectRef>
+          <a:fontRef idx="minor">
+            <a:schemeClr val="lt1"/>
+          </a:fontRef>
+        </p:style>
+        <p:txBody>
+          <a:bodyPr rtlCol="0" anchor="ctr"/>
+          <a:lstStyle/>
+          <a:p>
+            <a:pPr algn="ctr"/>
+          </a:p>
+        </p:txBody>
+      </p:sp>
+      <p:sp>
+        <p:nvSpPr>
+          <p:cNvPr id="20" name="Rectangle 19"/>
+          <p:cNvSpPr/>
+          <p:nvPr/>
+        </p:nvSpPr>
+        <p:spPr>
+          <a:xfrm>
+            <a:off x="5138928" y="1737360"/>
+            <a:ext cx="164592" cy="38100"/>
+          </a:xfrm>
+          <a:prstGeom prst="rect">
+            <a:avLst/>
+          </a:prstGeom>
+          <a:solidFill>
+            <a:srgbClr val="00D4FF"/>
+          </a:solidFill>
+          <a:ln>
+            <a:noFill/>
+          </a:ln>
+        </p:spPr>
+        <p:style>
+          <a:lnRef idx="1">
+            <a:schemeClr val="accent1"/>
+          </a:lnRef>
+          <a:fillRef idx="3">
+            <a:schemeClr val="accent1"/>
+          </a:fillRef>
+          <a:effectRef idx="2">
+            <a:schemeClr val="accent1"/>
+          </a:effectRef>
+          <a:fontRef idx="minor">
+            <a:schemeClr val="lt1"/>
+          </a:fontRef>
+        </p:style>
+        <p:txBody>
+          <a:bodyPr rtlCol="0" anchor="ctr"/>
+          <a:lstStyle/>
+          <a:p>
+            <a:pPr algn="ctr"/>
+          </a:p>
+        </p:txBody>
+      </p:sp>
+      <p:sp>
+        <p:nvSpPr>
+          <p:cNvPr id="21" name="Rectangle 20"/>
+          <p:cNvSpPr/>
+          <p:nvPr/>
+        </p:nvSpPr>
+        <p:spPr>
+          <a:xfrm>
+            <a:off x="5265420" y="1737360"/>
+            <a:ext cx="38100" cy="164592"/>
+          </a:xfrm>
+          <a:prstGeom prst="rect">
+            <a:avLst/>
+          </a:prstGeom>
+          <a:solidFill>
+            <a:srgbClr val="00D4FF"/>
+          </a:solidFill>
+          <a:ln>
+            <a:noFill/>
+          </a:ln>
+        </p:spPr>
+        <p:style>
+          <a:lnRef idx="1">
+            <a:schemeClr val="accent1"/>
+          </a:lnRef>
+          <a:fillRef idx="3">
+            <a:schemeClr val="accent1"/>
+          </a:fillRef>
+          <a:effectRef idx="2">
+            <a:schemeClr val="accent1"/>
+          </a:effectRef>
+          <a:fontRef idx="minor">
+            <a:schemeClr val="lt1"/>
+          </a:fontRef>
+        </p:style>
+        <p:txBody>
+          <a:bodyPr rtlCol="0" anchor="ctr"/>
+          <a:lstStyle/>
+          <a:p>
+            <a:pPr algn="ctr"/>
+          </a:p>
+        </p:txBody>
+      </p:sp>
+      <p:sp>
+        <p:nvSpPr>
+          <p:cNvPr id="22" name="Rectangle 21"/>
+          <p:cNvSpPr/>
+          <p:nvPr/>
+        </p:nvSpPr>
+        <p:spPr>
+          <a:xfrm>
+            <a:off x="731520" y="5722620"/>
+            <a:ext cx="164592" cy="38100"/>
+          </a:xfrm>
+          <a:prstGeom prst="rect">
+            <a:avLst/>
+          </a:prstGeom>
+          <a:solidFill>
+            <a:srgbClr val="4DA3FF"/>
+          </a:solidFill>
+          <a:ln>
+            <a:noFill/>
+          </a:ln>
+        </p:spPr>
+        <p:style>
+          <a:lnRef idx="1">
+            <a:schemeClr val="accent1"/>
+          </a:lnRef>
+          <a:fillRef idx="3">
+            <a:schemeClr val="accent1"/>
+          </a:fillRef>
+          <a:effectRef idx="2">
+            <a:schemeClr val="accent1"/>
+          </a:effectRef>
+          <a:fontRef idx="minor">
+            <a:schemeClr val="lt1"/>
+          </a:fontRef>
+        </p:style>
+        <p:txBody>
+          <a:bodyPr rtlCol="0" anchor="ctr"/>
+          <a:lstStyle/>
+          <a:p>
+            <a:pPr algn="ctr"/>
+          </a:p>
+        </p:txBody>
+      </p:sp>
+      <p:sp>
+        <p:nvSpPr>
+          <p:cNvPr id="23" name="Rectangle 22"/>
+          <p:cNvSpPr/>
+          <p:nvPr/>
+        </p:nvSpPr>
+        <p:spPr>
+          <a:xfrm>
+            <a:off x="731520" y="5596128"/>
+            <a:ext cx="38100" cy="164592"/>
+          </a:xfrm>
+          <a:prstGeom prst="rect">
+            <a:avLst/>
+          </a:prstGeom>
+          <a:solidFill>
+            <a:srgbClr val="4DA3FF"/>
+          </a:solidFill>
+          <a:ln>
+            <a:noFill/>
+          </a:ln>
+        </p:spPr>
+        <p:style>
+          <a:lnRef idx="1">
+            <a:schemeClr val="accent1"/>
+          </a:lnRef>
+          <a:fillRef idx="3">
+            <a:schemeClr val="accent1"/>
+          </a:fillRef>
+          <a:effectRef idx="2">
+            <a:schemeClr val="accent1"/>
+          </a:effectRef>
+          <a:fontRef idx="minor">
+            <a:schemeClr val="lt1"/>
+          </a:fontRef>
+        </p:style>
+        <p:txBody>
+          <a:bodyPr rtlCol="0" anchor="ctr"/>
+          <a:lstStyle/>
+          <a:p>
+            <a:pPr algn="ctr"/>
+          </a:p>
+        </p:txBody>
+      </p:sp>
+      <p:sp>
+        <p:nvSpPr>
+          <p:cNvPr id="24" name="Rectangle 23"/>
+          <p:cNvSpPr/>
+          <p:nvPr/>
+        </p:nvSpPr>
+        <p:spPr>
+          <a:xfrm>
+            <a:off x="5138928" y="5722620"/>
+            <a:ext cx="164592" cy="38100"/>
+          </a:xfrm>
+          <a:prstGeom prst="rect">
+            <a:avLst/>
+          </a:prstGeom>
+          <a:solidFill>
+            <a:srgbClr val="4DA3FF"/>
+          </a:solidFill>
+          <a:ln>
+            <a:noFill/>
+          </a:ln>
+        </p:spPr>
+        <p:style>
+          <a:lnRef idx="1">
+            <a:schemeClr val="accent1"/>
+          </a:lnRef>
+          <a:fillRef idx="3">
+            <a:schemeClr val="accent1"/>
+          </a:fillRef>
+          <a:effectRef idx="2">
+            <a:schemeClr val="accent1"/>
+          </a:effectRef>
+          <a:fontRef idx="minor">
+            <a:schemeClr val="lt1"/>
+          </a:fontRef>
+        </p:style>
+        <p:txBody>
+          <a:bodyPr rtlCol="0" anchor="ctr"/>
+          <a:lstStyle/>
+          <a:p>
+            <a:pPr algn="ctr"/>
+          </a:p>
+        </p:txBody>
+      </p:sp>
+      <p:sp>
+        <p:nvSpPr>
+          <p:cNvPr id="25" name="Rectangle 24"/>
+          <p:cNvSpPr/>
+          <p:nvPr/>
+        </p:nvSpPr>
+        <p:spPr>
+          <a:xfrm>
+            <a:off x="5265420" y="5596128"/>
+            <a:ext cx="38100" cy="164592"/>
+          </a:xfrm>
+          <a:prstGeom prst="rect">
+            <a:avLst/>
+          </a:prstGeom>
+          <a:solidFill>
+            <a:srgbClr val="4DA3FF"/>
+          </a:solidFill>
+          <a:ln>
+            <a:noFill/>
+          </a:ln>
+        </p:spPr>
+        <p:style>
+          <a:lnRef idx="1">
+            <a:schemeClr val="accent1"/>
+          </a:lnRef>
+          <a:fillRef idx="3">
+            <a:schemeClr val="accent1"/>
+          </a:fillRef>
+          <a:effectRef idx="2">
+            <a:schemeClr val="accent1"/>
+          </a:effectRef>
+          <a:fontRef idx="minor">
+            <a:schemeClr val="lt1"/>
+          </a:fontRef>
+        </p:style>
+        <p:txBody>
+          <a:bodyPr rtlCol="0" anchor="ctr"/>
+          <a:lstStyle/>
+          <a:p>
+            <a:pPr algn="ctr"/>
+          </a:p>
+        </p:txBody>
+      </p:sp>
+      <p:sp>
+        <p:nvSpPr>
+          <p:cNvPr id="26" name="Rectangle 25"/>
+          <p:cNvSpPr/>
+          <p:nvPr/>
+        </p:nvSpPr>
+        <p:spPr>
+          <a:xfrm>
+            <a:off x="731520" y="5760720"/>
+            <a:ext cx="4572000" cy="457200"/>
+          </a:xfrm>
+          <a:prstGeom prst="rect">
             <a:avLst/>
           </a:prstGeom>
           <a:solidFill>
             <a:srgbClr val="0A193C"/>
           </a:solidFill>
-          <a:ln w="10160">
+          <a:ln w="12700">
             <a:solidFill>
               <a:srgbClr val="4DA3FF"/>
             </a:solidFill>
@@ -9783,14 +11025,14 @@
       </p:sp>
       <p:sp>
         <p:nvSpPr>
-          <p:cNvPr id="18" name="TextBox 17"/>
+          <p:cNvPr id="27" name="TextBox 26"/>
           <p:cNvSpPr txBox="1"/>
           <p:nvPr/>
         </p:nvSpPr>
         <p:spPr>
           <a:xfrm>
-            <a:off x="914400" y="5669280"/>
-            <a:ext cx="4206240" cy="457200"/>
+            <a:off x="731520" y="5760720"/>
+            <a:ext cx="4572000" cy="457200"/>
           </a:xfrm>
           <a:prstGeom prst="rect">
             <a:avLst/>
@@ -9819,7 +11061,7 @@
       </p:sp>
       <p:sp>
         <p:nvSpPr>
-          <p:cNvPr id="19" name="Rounded Rectangle 18"/>
+          <p:cNvPr id="28" name="Rectangle 27"/>
           <p:cNvSpPr/>
           <p:nvPr/>
         </p:nvSpPr>
@@ -9828,7 +11070,7 @@
             <a:off x="5760720" y="1737360"/>
             <a:ext cx="5669280" cy="4572000"/>
           </a:xfrm>
-          <a:prstGeom prst="roundRect">
+          <a:prstGeom prst="rect">
             <a:avLst/>
           </a:prstGeom>
           <a:solidFill>
@@ -9864,7 +11106,7 @@
       </p:sp>
       <p:sp>
         <p:nvSpPr>
-          <p:cNvPr id="20" name="Rectangle 19"/>
+          <p:cNvPr id="29" name="Rectangle 28"/>
           <p:cNvSpPr/>
           <p:nvPr/>
         </p:nvSpPr>
@@ -9907,7 +11149,7 @@
       </p:sp>
       <p:sp>
         <p:nvSpPr>
-          <p:cNvPr id="21" name="TextBox 20"/>
+          <p:cNvPr id="30" name="TextBox 29"/>
           <p:cNvSpPr txBox="1"/>
           <p:nvPr/>
         </p:nvSpPr>
@@ -9943,7 +11185,7 @@
       </p:sp>
       <p:sp>
         <p:nvSpPr>
-          <p:cNvPr id="22" name="TextBox 21"/>
+          <p:cNvPr id="31" name="TextBox 30"/>
           <p:cNvSpPr txBox="1"/>
           <p:nvPr/>
         </p:nvSpPr>
@@ -10080,7 +11322,7 @@
       </p:sp>
       <p:sp>
         <p:nvSpPr>
-          <p:cNvPr id="23" name="Rounded Rectangle 22"/>
+          <p:cNvPr id="32" name="Rectangle 31"/>
           <p:cNvSpPr/>
           <p:nvPr/>
         </p:nvSpPr>
@@ -10089,7 +11331,7 @@
             <a:off x="9875520" y="2331720"/>
             <a:ext cx="1188720" cy="256032"/>
           </a:xfrm>
-          <a:prstGeom prst="roundRect">
+          <a:prstGeom prst="rect">
             <a:avLst/>
           </a:prstGeom>
           <a:solidFill>
@@ -10125,7 +11367,7 @@
       </p:sp>
       <p:sp>
         <p:nvSpPr>
-          <p:cNvPr id="24" name="TextBox 23"/>
+          <p:cNvPr id="33" name="TextBox 32"/>
           <p:cNvSpPr txBox="1"/>
           <p:nvPr/>
         </p:nvSpPr>
@@ -10161,7 +11403,7 @@
       </p:sp>
       <p:sp>
         <p:nvSpPr>
-          <p:cNvPr id="25" name="Rounded Rectangle 24"/>
+          <p:cNvPr id="34" name="Rectangle 33"/>
           <p:cNvSpPr/>
           <p:nvPr/>
         </p:nvSpPr>
@@ -10170,7 +11412,7 @@
             <a:off x="9875520" y="2898648"/>
             <a:ext cx="1188720" cy="256032"/>
           </a:xfrm>
-          <a:prstGeom prst="roundRect">
+          <a:prstGeom prst="rect">
             <a:avLst/>
           </a:prstGeom>
           <a:solidFill>
@@ -10206,7 +11448,7 @@
       </p:sp>
       <p:sp>
         <p:nvSpPr>
-          <p:cNvPr id="26" name="TextBox 25"/>
+          <p:cNvPr id="35" name="TextBox 34"/>
           <p:cNvSpPr txBox="1"/>
           <p:nvPr/>
         </p:nvSpPr>
@@ -10235,14 +11477,14 @@
               </a:defRPr>
             </a:pPr>
             <a:r>
-              <a:t>± 10cm Accuracy</a:t>
-            </a:r>
-          </a:p>
-        </p:txBody>
-      </p:sp>
-      <p:sp>
-        <p:nvSpPr>
-          <p:cNvPr id="27" name="Rounded Rectangle 26"/>
+              <a:t>± 10cm</a:t>
+            </a:r>
+          </a:p>
+        </p:txBody>
+      </p:sp>
+      <p:sp>
+        <p:nvSpPr>
+          <p:cNvPr id="36" name="Rectangle 35"/>
           <p:cNvSpPr/>
           <p:nvPr/>
         </p:nvSpPr>
@@ -10251,7 +11493,7 @@
             <a:off x="9875520" y="3465576"/>
             <a:ext cx="1188720" cy="256032"/>
           </a:xfrm>
-          <a:prstGeom prst="roundRect">
+          <a:prstGeom prst="rect">
             <a:avLst/>
           </a:prstGeom>
           <a:solidFill>
@@ -10287,7 +11529,7 @@
       </p:sp>
       <p:sp>
         <p:nvSpPr>
-          <p:cNvPr id="28" name="TextBox 27"/>
+          <p:cNvPr id="37" name="TextBox 36"/>
           <p:cNvSpPr txBox="1"/>
           <p:nvPr/>
         </p:nvSpPr>
@@ -10316,14 +11558,14 @@
               </a:defRPr>
             </a:pPr>
             <a:r>
-              <a:t>90% Less Effort</a:t>
-            </a:r>
-          </a:p>
-        </p:txBody>
-      </p:sp>
-      <p:sp>
-        <p:nvSpPr>
-          <p:cNvPr id="29" name="Rounded Rectangle 28"/>
+              <a:t>90% Less</a:t>
+            </a:r>
+          </a:p>
+        </p:txBody>
+      </p:sp>
+      <p:sp>
+        <p:nvSpPr>
+          <p:cNvPr id="38" name="Rectangle 37"/>
           <p:cNvSpPr/>
           <p:nvPr/>
         </p:nvSpPr>
@@ -10332,7 +11574,7 @@
             <a:off x="9875520" y="4032504"/>
             <a:ext cx="1188720" cy="256032"/>
           </a:xfrm>
-          <a:prstGeom prst="roundRect">
+          <a:prstGeom prst="rect">
             <a:avLst/>
           </a:prstGeom>
           <a:solidFill>
@@ -10368,7 +11610,7 @@
       </p:sp>
       <p:sp>
         <p:nvSpPr>
-          <p:cNvPr id="30" name="TextBox 29"/>
+          <p:cNvPr id="39" name="TextBox 38"/>
           <p:cNvSpPr txBox="1"/>
           <p:nvPr/>
         </p:nvSpPr>
@@ -10397,14 +11639,14 @@
               </a:defRPr>
             </a:pPr>
             <a:r>
-              <a:t>&lt; 2 Sec Alert</a:t>
-            </a:r>
-          </a:p>
-        </p:txBody>
-      </p:sp>
-      <p:sp>
-        <p:nvSpPr>
-          <p:cNvPr id="31" name="Rounded Rectangle 30"/>
+              <a:t>&lt; 2 Sec</a:t>
+            </a:r>
+          </a:p>
+        </p:txBody>
+      </p:sp>
+      <p:sp>
+        <p:nvSpPr>
+          <p:cNvPr id="40" name="Rectangle 39"/>
           <p:cNvSpPr/>
           <p:nvPr/>
         </p:nvSpPr>
@@ -10413,7 +11655,7 @@
             <a:off x="9875520" y="4599431"/>
             <a:ext cx="1188720" cy="256032"/>
           </a:xfrm>
-          <a:prstGeom prst="roundRect">
+          <a:prstGeom prst="rect">
             <a:avLst/>
           </a:prstGeom>
           <a:solidFill>
@@ -10449,7 +11691,7 @@
       </p:sp>
       <p:sp>
         <p:nvSpPr>
-          <p:cNvPr id="32" name="TextBox 31"/>
+          <p:cNvPr id="41" name="TextBox 40"/>
           <p:cNvSpPr txBox="1"/>
           <p:nvPr/>
         </p:nvSpPr>
@@ -10478,14 +11720,14 @@
               </a:defRPr>
             </a:pPr>
             <a:r>
-              <a:t>30% Cost Saving</a:t>
-            </a:r>
-          </a:p>
-        </p:txBody>
-      </p:sp>
-      <p:sp>
-        <p:nvSpPr>
-          <p:cNvPr id="33" name="Rounded Rectangle 32"/>
+              <a:t>30% Save</a:t>
+            </a:r>
+          </a:p>
+        </p:txBody>
+      </p:sp>
+      <p:sp>
+        <p:nvSpPr>
+          <p:cNvPr id="42" name="Rectangle 41"/>
           <p:cNvSpPr/>
           <p:nvPr/>
         </p:nvSpPr>
@@ -10494,7 +11736,7 @@
             <a:off x="9875520" y="5166360"/>
             <a:ext cx="1188720" cy="256032"/>
           </a:xfrm>
-          <a:prstGeom prst="roundRect">
+          <a:prstGeom prst="rect">
             <a:avLst/>
           </a:prstGeom>
           <a:solidFill>
@@ -10530,7 +11772,7 @@
       </p:sp>
       <p:sp>
         <p:nvSpPr>
-          <p:cNvPr id="34" name="TextBox 33"/>
+          <p:cNvPr id="43" name="TextBox 42"/>
           <p:cNvSpPr txBox="1"/>
           <p:nvPr/>
         </p:nvSpPr>
@@ -10566,7 +11808,7 @@
       </p:sp>
       <p:sp>
         <p:nvSpPr>
-          <p:cNvPr id="35" name="Rounded Rectangle 34"/>
+          <p:cNvPr id="44" name="Rectangle 43"/>
           <p:cNvSpPr/>
           <p:nvPr/>
         </p:nvSpPr>
@@ -10575,7 +11817,7 @@
             <a:off x="6080760" y="5623560"/>
             <a:ext cx="5029200" cy="548640"/>
           </a:xfrm>
-          <a:prstGeom prst="roundRect">
+          <a:prstGeom prst="rect">
             <a:avLst/>
           </a:prstGeom>
           <a:solidFill>
@@ -10611,14 +11853,14 @@
       </p:sp>
       <p:sp>
         <p:nvSpPr>
-          <p:cNvPr id="36" name="TextBox 35"/>
+          <p:cNvPr id="45" name="TextBox 44"/>
           <p:cNvSpPr txBox="1"/>
           <p:nvPr/>
         </p:nvSpPr>
         <p:spPr>
           <a:xfrm>
-            <a:off x="6172200" y="5669280"/>
-            <a:ext cx="4846320" cy="457200"/>
+            <a:off x="6080760" y="5623560"/>
+            <a:ext cx="5029200" cy="548640"/>
           </a:xfrm>
           <a:prstGeom prst="rect">
             <a:avLst/>
@@ -10640,14 +11882,14 @@
               </a:defRPr>
             </a:pPr>
             <a:r>
-              <a:t>✓  Expected Result: 95% Leak Detection Accuracy with Edge AI</a:t>
-            </a:r>
-          </a:p>
-        </p:txBody>
-      </p:sp>
-      <p:sp>
-        <p:nvSpPr>
-          <p:cNvPr id="37" name="Oval 36"/>
+              <a:t>✓  Expected: 95% Leak Detection Accuracy with Edge AI</a:t>
+            </a:r>
+          </a:p>
+        </p:txBody>
+      </p:sp>
+      <p:sp>
+        <p:nvSpPr>
+          <p:cNvPr id="46" name="Oval 45"/>
           <p:cNvSpPr/>
           <p:nvPr/>
         </p:nvSpPr>
@@ -10690,7 +11932,7 @@
       </p:sp>
       <p:sp>
         <p:nvSpPr>
-          <p:cNvPr id="38" name="Oval 37"/>
+          <p:cNvPr id="47" name="Oval 46"/>
           <p:cNvSpPr/>
           <p:nvPr/>
         </p:nvSpPr>
@@ -10733,7 +11975,7 @@
       </p:sp>
       <p:sp>
         <p:nvSpPr>
-          <p:cNvPr id="39" name="Oval 38"/>
+          <p:cNvPr id="48" name="Oval 47"/>
           <p:cNvSpPr/>
           <p:nvPr/>
         </p:nvSpPr>
@@ -10776,7 +12018,7 @@
       </p:sp>
       <p:sp>
         <p:nvSpPr>
-          <p:cNvPr id="40" name="Oval 39"/>
+          <p:cNvPr id="49" name="Oval 48"/>
           <p:cNvSpPr/>
           <p:nvPr/>
         </p:nvSpPr>
@@ -10819,7 +12061,7 @@
       </p:sp>
       <p:sp>
         <p:nvSpPr>
-          <p:cNvPr id="41" name="Oval 40"/>
+          <p:cNvPr id="50" name="Oval 49"/>
           <p:cNvSpPr/>
           <p:nvPr/>
         </p:nvSpPr>
@@ -10862,7 +12104,7 @@
       </p:sp>
       <p:sp>
         <p:nvSpPr>
-          <p:cNvPr id="42" name="Oval 41"/>
+          <p:cNvPr id="51" name="Oval 50"/>
           <p:cNvSpPr/>
           <p:nvPr/>
         </p:nvSpPr>
@@ -10905,7 +12147,7 @@
       </p:sp>
       <p:sp>
         <p:nvSpPr>
-          <p:cNvPr id="43" name="Oval 42"/>
+          <p:cNvPr id="52" name="Oval 51"/>
           <p:cNvSpPr/>
           <p:nvPr/>
         </p:nvSpPr>
@@ -10948,7 +12190,7 @@
       </p:sp>
       <p:sp>
         <p:nvSpPr>
-          <p:cNvPr id="44" name="Oval 43"/>
+          <p:cNvPr id="53" name="Oval 52"/>
           <p:cNvSpPr/>
           <p:nvPr/>
         </p:nvSpPr>
@@ -10991,7 +12233,7 @@
       </p:sp>
       <p:sp>
         <p:nvSpPr>
-          <p:cNvPr id="45" name="Oval 44"/>
+          <p:cNvPr id="54" name="Oval 53"/>
           <p:cNvSpPr/>
           <p:nvPr/>
         </p:nvSpPr>
@@ -11034,7 +12276,7 @@
       </p:sp>
       <p:sp>
         <p:nvSpPr>
-          <p:cNvPr id="46" name="Oval 45"/>
+          <p:cNvPr id="55" name="Oval 54"/>
           <p:cNvSpPr/>
           <p:nvPr/>
         </p:nvSpPr>
@@ -11077,7 +12319,7 @@
       </p:sp>
       <p:sp>
         <p:nvSpPr>
-          <p:cNvPr id="47" name="Oval 46"/>
+          <p:cNvPr id="56" name="Oval 55"/>
           <p:cNvSpPr/>
           <p:nvPr/>
         </p:nvSpPr>
@@ -11120,7 +12362,7 @@
       </p:sp>
       <p:sp>
         <p:nvSpPr>
-          <p:cNvPr id="48" name="Oval 47"/>
+          <p:cNvPr id="57" name="Oval 56"/>
           <p:cNvSpPr/>
           <p:nvPr/>
         </p:nvSpPr>
@@ -11798,7 +13040,7 @@
       </p:sp>
       <p:sp>
         <p:nvSpPr>
-          <p:cNvPr id="17" name="Rounded Rectangle 16"/>
+          <p:cNvPr id="17" name="Rectangle 16"/>
           <p:cNvSpPr/>
           <p:nvPr/>
         </p:nvSpPr>
@@ -11807,7 +13049,7 @@
             <a:off x="4206240" y="1737360"/>
             <a:ext cx="3749039" cy="384048"/>
           </a:xfrm>
-          <a:prstGeom prst="roundRect">
+          <a:prstGeom prst="rect">
             <a:avLst/>
           </a:prstGeom>
           <a:solidFill>
@@ -11896,7 +13138,7 @@
       </p:sp>
       <p:sp>
         <p:nvSpPr>
-          <p:cNvPr id="19" name="Rounded Rectangle 18"/>
+          <p:cNvPr id="19" name="Rectangle 18"/>
           <p:cNvSpPr/>
           <p:nvPr/>
         </p:nvSpPr>
@@ -11905,7 +13147,7 @@
             <a:off x="4206240" y="2276856"/>
             <a:ext cx="3749039" cy="384048"/>
           </a:xfrm>
-          <a:prstGeom prst="roundRect">
+          <a:prstGeom prst="rect">
             <a:avLst/>
           </a:prstGeom>
           <a:solidFill>
@@ -11994,7 +13236,7 @@
       </p:sp>
       <p:sp>
         <p:nvSpPr>
-          <p:cNvPr id="21" name="Rounded Rectangle 20"/>
+          <p:cNvPr id="21" name="Rectangle 20"/>
           <p:cNvSpPr/>
           <p:nvPr/>
         </p:nvSpPr>
@@ -12003,7 +13245,7 @@
             <a:off x="4206240" y="2816352"/>
             <a:ext cx="3749039" cy="384048"/>
           </a:xfrm>
-          <a:prstGeom prst="roundRect">
+          <a:prstGeom prst="rect">
             <a:avLst/>
           </a:prstGeom>
           <a:solidFill>
@@ -12092,7 +13334,7 @@
       </p:sp>
       <p:sp>
         <p:nvSpPr>
-          <p:cNvPr id="23" name="Rounded Rectangle 22"/>
+          <p:cNvPr id="23" name="Rectangle 22"/>
           <p:cNvSpPr/>
           <p:nvPr/>
         </p:nvSpPr>
@@ -12101,7 +13343,7 @@
             <a:off x="4206240" y="3355848"/>
             <a:ext cx="3749039" cy="384048"/>
           </a:xfrm>
-          <a:prstGeom prst="roundRect">
+          <a:prstGeom prst="rect">
             <a:avLst/>
           </a:prstGeom>
           <a:solidFill>
@@ -12190,7 +13432,7 @@
       </p:sp>
       <p:sp>
         <p:nvSpPr>
-          <p:cNvPr id="25" name="Rounded Rectangle 24"/>
+          <p:cNvPr id="25" name="Rectangle 24"/>
           <p:cNvSpPr/>
           <p:nvPr/>
         </p:nvSpPr>
@@ -12199,7 +13441,7 @@
             <a:off x="4206240" y="3895344"/>
             <a:ext cx="3749039" cy="384048"/>
           </a:xfrm>
-          <a:prstGeom prst="roundRect">
+          <a:prstGeom prst="rect">
             <a:avLst/>
           </a:prstGeom>
           <a:solidFill>
@@ -12288,7 +13530,7 @@
       </p:sp>
       <p:sp>
         <p:nvSpPr>
-          <p:cNvPr id="27" name="Rounded Rectangle 26"/>
+          <p:cNvPr id="27" name="Rectangle 26"/>
           <p:cNvSpPr/>
           <p:nvPr/>
         </p:nvSpPr>
@@ -12297,7 +13539,7 @@
             <a:off x="4206240" y="4434840"/>
             <a:ext cx="3749039" cy="384048"/>
           </a:xfrm>
-          <a:prstGeom prst="roundRect">
+          <a:prstGeom prst="rect">
             <a:avLst/>
           </a:prstGeom>
           <a:solidFill>
@@ -12386,7 +13628,7 @@
       </p:sp>
       <p:sp>
         <p:nvSpPr>
-          <p:cNvPr id="29" name="Rounded Rectangle 28"/>
+          <p:cNvPr id="29" name="Rectangle 28"/>
           <p:cNvSpPr/>
           <p:nvPr/>
         </p:nvSpPr>
@@ -12395,7 +13637,7 @@
             <a:off x="4206240" y="4974336"/>
             <a:ext cx="3749039" cy="384048"/>
           </a:xfrm>
-          <a:prstGeom prst="roundRect">
+          <a:prstGeom prst="rect">
             <a:avLst/>
           </a:prstGeom>
           <a:solidFill>
@@ -12484,7 +13726,7 @@
       </p:sp>
       <p:sp>
         <p:nvSpPr>
-          <p:cNvPr id="31" name="Rounded Rectangle 30"/>
+          <p:cNvPr id="31" name="Rectangle 30"/>
           <p:cNvSpPr/>
           <p:nvPr/>
         </p:nvSpPr>
@@ -12493,7 +13735,7 @@
             <a:off x="4206240" y="5513832"/>
             <a:ext cx="3749039" cy="384048"/>
           </a:xfrm>
-          <a:prstGeom prst="roundRect">
+          <a:prstGeom prst="rect">
             <a:avLst/>
           </a:prstGeom>
           <a:solidFill>
@@ -12582,7 +13824,7 @@
       </p:sp>
       <p:sp>
         <p:nvSpPr>
-          <p:cNvPr id="33" name="Rounded Rectangle 32"/>
+          <p:cNvPr id="33" name="Rectangle 32"/>
           <p:cNvSpPr/>
           <p:nvPr/>
         </p:nvSpPr>
@@ -12591,7 +13833,7 @@
             <a:off x="4206240" y="6053328"/>
             <a:ext cx="3749039" cy="384048"/>
           </a:xfrm>
-          <a:prstGeom prst="roundRect">
+          <a:prstGeom prst="rect">
             <a:avLst/>
           </a:prstGeom>
           <a:solidFill>
@@ -12637,7 +13879,7 @@
       </p:sp>
       <p:sp>
         <p:nvSpPr>
-          <p:cNvPr id="34" name="Rounded Rectangle 33"/>
+          <p:cNvPr id="34" name="Rectangle 33"/>
           <p:cNvSpPr/>
           <p:nvPr/>
         </p:nvSpPr>
@@ -12646,7 +13888,7 @@
             <a:off x="731520" y="1737360"/>
             <a:ext cx="2651760" cy="1417320"/>
           </a:xfrm>
-          <a:prstGeom prst="roundRect">
+          <a:prstGeom prst="rect">
             <a:avLst/>
           </a:prstGeom>
           <a:solidFill>
@@ -12801,7 +14043,7 @@
       </p:sp>
       <p:sp>
         <p:nvSpPr>
-          <p:cNvPr id="38" name="Rounded Rectangle 37"/>
+          <p:cNvPr id="38" name="Rectangle 37"/>
           <p:cNvSpPr/>
           <p:nvPr/>
         </p:nvSpPr>
@@ -12810,7 +14052,7 @@
             <a:off x="914400" y="2788920"/>
             <a:ext cx="1097280" cy="228600"/>
           </a:xfrm>
-          <a:prstGeom prst="roundRect">
+          <a:prstGeom prst="rect">
             <a:avLst/>
           </a:prstGeom>
           <a:solidFill>
@@ -12882,7 +14124,7 @@
       </p:sp>
       <p:sp>
         <p:nvSpPr>
-          <p:cNvPr id="40" name="Rounded Rectangle 39"/>
+          <p:cNvPr id="40" name="Rectangle 39"/>
           <p:cNvSpPr/>
           <p:nvPr/>
         </p:nvSpPr>
@@ -12891,7 +14133,7 @@
             <a:off x="731520" y="3337560"/>
             <a:ext cx="2651760" cy="1417320"/>
           </a:xfrm>
-          <a:prstGeom prst="roundRect">
+          <a:prstGeom prst="rect">
             <a:avLst/>
           </a:prstGeom>
           <a:solidFill>
@@ -13046,7 +14288,7 @@
       </p:sp>
       <p:sp>
         <p:nvSpPr>
-          <p:cNvPr id="44" name="Rounded Rectangle 43"/>
+          <p:cNvPr id="44" name="Rectangle 43"/>
           <p:cNvSpPr/>
           <p:nvPr/>
         </p:nvSpPr>
@@ -13055,7 +14297,7 @@
             <a:off x="914400" y="4389120"/>
             <a:ext cx="1097280" cy="228600"/>
           </a:xfrm>
-          <a:prstGeom prst="roundRect">
+          <a:prstGeom prst="rect">
             <a:avLst/>
           </a:prstGeom>
           <a:solidFill>
@@ -13127,7 +14369,7 @@
       </p:sp>
       <p:sp>
         <p:nvSpPr>
-          <p:cNvPr id="46" name="Rounded Rectangle 45"/>
+          <p:cNvPr id="46" name="Rectangle 45"/>
           <p:cNvSpPr/>
           <p:nvPr/>
         </p:nvSpPr>
@@ -13136,7 +14378,7 @@
             <a:off x="731520" y="4937760"/>
             <a:ext cx="2651760" cy="1417320"/>
           </a:xfrm>
-          <a:prstGeom prst="roundRect">
+          <a:prstGeom prst="rect">
             <a:avLst/>
           </a:prstGeom>
           <a:solidFill>
@@ -13291,7 +14533,7 @@
       </p:sp>
       <p:sp>
         <p:nvSpPr>
-          <p:cNvPr id="50" name="Rounded Rectangle 49"/>
+          <p:cNvPr id="50" name="Rectangle 49"/>
           <p:cNvSpPr/>
           <p:nvPr/>
         </p:nvSpPr>
@@ -13300,7 +14542,7 @@
             <a:off x="914400" y="5989320"/>
             <a:ext cx="1097280" cy="228600"/>
           </a:xfrm>
-          <a:prstGeom prst="roundRect">
+          <a:prstGeom prst="rect">
             <a:avLst/>
           </a:prstGeom>
           <a:solidFill>
@@ -13372,7 +14614,7 @@
       </p:sp>
       <p:sp>
         <p:nvSpPr>
-          <p:cNvPr id="52" name="Rounded Rectangle 51"/>
+          <p:cNvPr id="52" name="Rectangle 51"/>
           <p:cNvSpPr/>
           <p:nvPr/>
         </p:nvSpPr>
@@ -13381,7 +14623,7 @@
             <a:off x="9144000" y="1737360"/>
             <a:ext cx="2377440" cy="1417320"/>
           </a:xfrm>
-          <a:prstGeom prst="roundRect">
+          <a:prstGeom prst="rect">
             <a:avLst/>
           </a:prstGeom>
           <a:solidFill>
@@ -13536,7 +14778,7 @@
       </p:sp>
       <p:sp>
         <p:nvSpPr>
-          <p:cNvPr id="56" name="Rounded Rectangle 55"/>
+          <p:cNvPr id="56" name="Rectangle 55"/>
           <p:cNvSpPr/>
           <p:nvPr/>
         </p:nvSpPr>
@@ -13545,7 +14787,7 @@
             <a:off x="9326880" y="2788920"/>
             <a:ext cx="1097280" cy="228600"/>
           </a:xfrm>
-          <a:prstGeom prst="roundRect">
+          <a:prstGeom prst="rect">
             <a:avLst/>
           </a:prstGeom>
           <a:solidFill>
@@ -13617,7 +14859,7 @@
       </p:sp>
       <p:sp>
         <p:nvSpPr>
-          <p:cNvPr id="58" name="Rounded Rectangle 57"/>
+          <p:cNvPr id="58" name="Rectangle 57"/>
           <p:cNvSpPr/>
           <p:nvPr/>
         </p:nvSpPr>
@@ -13626,7 +14868,7 @@
             <a:off x="9144000" y="3337560"/>
             <a:ext cx="2377440" cy="1417320"/>
           </a:xfrm>
-          <a:prstGeom prst="roundRect">
+          <a:prstGeom prst="rect">
             <a:avLst/>
           </a:prstGeom>
           <a:solidFill>
@@ -13781,7 +15023,7 @@
       </p:sp>
       <p:sp>
         <p:nvSpPr>
-          <p:cNvPr id="62" name="Rounded Rectangle 61"/>
+          <p:cNvPr id="62" name="Rectangle 61"/>
           <p:cNvSpPr/>
           <p:nvPr/>
         </p:nvSpPr>
@@ -13790,7 +15032,7 @@
             <a:off x="9326880" y="4389120"/>
             <a:ext cx="1097280" cy="228600"/>
           </a:xfrm>
-          <a:prstGeom prst="roundRect">
+          <a:prstGeom prst="rect">
             <a:avLst/>
           </a:prstGeom>
           <a:solidFill>
@@ -13862,7 +15104,7 @@
       </p:sp>
       <p:sp>
         <p:nvSpPr>
-          <p:cNvPr id="64" name="Rounded Rectangle 63"/>
+          <p:cNvPr id="64" name="Rectangle 63"/>
           <p:cNvSpPr/>
           <p:nvPr/>
         </p:nvSpPr>
@@ -13871,7 +15113,7 @@
             <a:off x="9144000" y="4937760"/>
             <a:ext cx="2377440" cy="1417320"/>
           </a:xfrm>
-          <a:prstGeom prst="roundRect">
+          <a:prstGeom prst="rect">
             <a:avLst/>
           </a:prstGeom>
           <a:solidFill>
@@ -14026,7 +15268,7 @@
       </p:sp>
       <p:sp>
         <p:nvSpPr>
-          <p:cNvPr id="68" name="Rounded Rectangle 67"/>
+          <p:cNvPr id="68" name="Rectangle 67"/>
           <p:cNvSpPr/>
           <p:nvPr/>
         </p:nvSpPr>
@@ -14035,7 +15277,7 @@
             <a:off x="9326880" y="5989320"/>
             <a:ext cx="1097280" cy="228600"/>
           </a:xfrm>
-          <a:prstGeom prst="roundRect">
+          <a:prstGeom prst="rect">
             <a:avLst/>
           </a:prstGeom>
           <a:solidFill>
@@ -15258,7 +16500,7 @@
       </p:sp>
       <p:sp>
         <p:nvSpPr>
-          <p:cNvPr id="17" name="Rounded Rectangle 16"/>
+          <p:cNvPr id="17" name="Rectangle 16"/>
           <p:cNvSpPr/>
           <p:nvPr/>
         </p:nvSpPr>
@@ -15267,7 +16509,7 @@
             <a:off x="731520" y="1737360"/>
             <a:ext cx="5669280" cy="3108960"/>
           </a:xfrm>
-          <a:prstGeom prst="roundRect">
+          <a:prstGeom prst="rect">
             <a:avLst/>
           </a:prstGeom>
           <a:solidFill>
@@ -15483,7 +16725,7 @@
       </p:sp>
       <p:sp>
         <p:nvSpPr>
-          <p:cNvPr id="21" name="Rounded Rectangle 20"/>
+          <p:cNvPr id="21" name="Rectangle 20"/>
           <p:cNvSpPr/>
           <p:nvPr/>
         </p:nvSpPr>
@@ -15492,7 +16734,7 @@
             <a:off x="1051560" y="4297680"/>
             <a:ext cx="1554480" cy="457200"/>
           </a:xfrm>
-          <a:prstGeom prst="roundRect">
+          <a:prstGeom prst="rect">
             <a:avLst/>
           </a:prstGeom>
           <a:solidFill>
@@ -15600,7 +16842,7 @@
       </p:sp>
       <p:sp>
         <p:nvSpPr>
-          <p:cNvPr id="24" name="Rounded Rectangle 23"/>
+          <p:cNvPr id="24" name="Rectangle 23"/>
           <p:cNvSpPr/>
           <p:nvPr/>
         </p:nvSpPr>
@@ -15609,7 +16851,7 @@
             <a:off x="2788920" y="4297680"/>
             <a:ext cx="1554480" cy="457200"/>
           </a:xfrm>
-          <a:prstGeom prst="roundRect">
+          <a:prstGeom prst="rect">
             <a:avLst/>
           </a:prstGeom>
           <a:solidFill>
@@ -15717,7 +16959,7 @@
       </p:sp>
       <p:sp>
         <p:nvSpPr>
-          <p:cNvPr id="27" name="Rounded Rectangle 26"/>
+          <p:cNvPr id="27" name="Rectangle 26"/>
           <p:cNvSpPr/>
           <p:nvPr/>
         </p:nvSpPr>
@@ -15726,7 +16968,7 @@
             <a:off x="4526279" y="4297680"/>
             <a:ext cx="1554480" cy="457200"/>
           </a:xfrm>
-          <a:prstGeom prst="roundRect">
+          <a:prstGeom prst="rect">
             <a:avLst/>
           </a:prstGeom>
           <a:solidFill>
@@ -15834,7 +17076,7 @@
       </p:sp>
       <p:sp>
         <p:nvSpPr>
-          <p:cNvPr id="30" name="Rounded Rectangle 29"/>
+          <p:cNvPr id="30" name="Rectangle 29"/>
           <p:cNvSpPr/>
           <p:nvPr/>
         </p:nvSpPr>
@@ -15843,7 +17085,7 @@
             <a:off x="6858000" y="1737360"/>
             <a:ext cx="4572000" cy="3108960"/>
           </a:xfrm>
-          <a:prstGeom prst="roundRect">
+          <a:prstGeom prst="rect">
             <a:avLst/>
           </a:prstGeom>
           <a:solidFill>
@@ -16106,7 +17348,7 @@
       </p:sp>
       <p:sp>
         <p:nvSpPr>
-          <p:cNvPr id="37" name="Rounded Rectangle 36"/>
+          <p:cNvPr id="37" name="Rectangle 36"/>
           <p:cNvSpPr/>
           <p:nvPr/>
         </p:nvSpPr>
@@ -16115,7 +17357,7 @@
             <a:off x="8229600" y="4526280"/>
             <a:ext cx="640080" cy="640080"/>
           </a:xfrm>
-          <a:prstGeom prst="roundRect">
+          <a:prstGeom prst="rect">
             <a:avLst/>
           </a:prstGeom>
           <a:solidFill>
@@ -16263,7 +17505,7 @@
               </a:defRPr>
             </a:pPr>
             <a:r>
-              <a:t>LeakGuard | Autonomous Edge-AI Robot for Compressed-Air Leak Detection | Team Lead: Sachin.N (CCE) | Rithish.P (CCE) | Dharun.V (MECH)</a:t>
+              <a:t>LeakGuard | Autonomous Edge-AI Robot for Compressed-Air Leak Detection | Sachin.N (CCE) | Rithish.P (CCE) | Dharun.V (MECH)</a:t>
             </a:r>
           </a:p>
         </p:txBody>

</xml_diff>